<commit_message>
update the temple of pptx
</commit_message>
<xml_diff>
--- a/template.pptx
+++ b/template.pptx
@@ -1,14 +1,20 @@
 
 <file path=ppt/presentation.xml><?xml version="1.0" encoding="utf-8"?>
-<p:presentation xmlns:a="http://schemas.openxmlformats.org/drawingml/2006/main" xmlns:r="http://schemas.openxmlformats.org/officeDocument/2006/relationships" xmlns:p="http://schemas.openxmlformats.org/presentationml/2006/main" saveSubsetFonts="1">
+<p:presentation xmlns:a="http://schemas.openxmlformats.org/drawingml/2006/main" xmlns:r="http://schemas.openxmlformats.org/officeDocument/2006/relationships" xmlns:p="http://schemas.openxmlformats.org/presentationml/2006/main" embedTrueTypeFonts="1" saveSubsetFonts="1">
   <p:sldMasterIdLst>
-    <p:sldMasterId id="2147483660" r:id="rId4"/>
+    <p:sldMasterId id="2147483648" r:id="rId1"/>
   </p:sldMasterIdLst>
   <p:sldIdLst>
-    <p:sldId id="454" r:id="rId5"/>
+    <p:sldId id="259" r:id="rId2"/>
   </p:sldIdLst>
-  <p:sldSz cx="12192000" cy="6858000"/>
+  <p:sldSz cx="18288000" cy="10287000"/>
   <p:notesSz cx="6858000" cy="9144000"/>
+  <p:embeddedFontLst>
+    <p:embeddedFont>
+      <p:font typeface="Anton" pitchFamily="2" charset="0"/>
+      <p:regular r:id="rId3"/>
+    </p:embeddedFont>
+  </p:embeddedFontLst>
   <p:defaultTextStyle>
     <a:defPPr>
       <a:defRPr lang="en-US"/>
@@ -106,7 +112,18 @@
   </p:defaultTextStyle>
   <p:extLst>
     <p:ext uri="{EFAFB233-063F-42B5-8137-9DF3F51BA10A}">
-      <p15:sldGuideLst xmlns:p15="http://schemas.microsoft.com/office/powerpoint/2012/main"/>
+      <p15:sldGuideLst xmlns:p15="http://schemas.microsoft.com/office/powerpoint/2012/main">
+        <p15:guide id="1" orient="horz" pos="2160">
+          <p15:clr>
+            <a:srgbClr val="A4A3A4"/>
+          </p15:clr>
+        </p15:guide>
+        <p15:guide id="2" pos="2880">
+          <p15:clr>
+            <a:srgbClr val="A4A3A4"/>
+          </p15:clr>
+        </p15:guide>
+      </p15:sldGuideLst>
     </p:ext>
   </p:extLst>
 </p:presentation>
@@ -141,17 +158,13 @@
         </p:nvSpPr>
         <p:spPr>
           <a:xfrm>
-            <a:off x="1524000" y="1122363"/>
-            <a:ext cx="9144000" cy="2387600"/>
+            <a:off x="685800" y="2130425"/>
+            <a:ext cx="7772400" cy="1470025"/>
           </a:xfrm>
         </p:spPr>
         <p:txBody>
-          <a:bodyPr anchor="b"/>
-          <a:lstStyle>
-            <a:lvl1pPr algn="ctr">
-              <a:defRPr sz="6000"/>
-            </a:lvl1pPr>
-          </a:lstStyle>
+          <a:bodyPr/>
+          <a:lstStyle/>
           <a:p>
             <a:r>
               <a:rPr lang="en-US"/>
@@ -172,8 +185,8 @@
         </p:nvSpPr>
         <p:spPr>
           <a:xfrm>
-            <a:off x="1524000" y="3602038"/>
-            <a:ext cx="9144000" cy="1655762"/>
+            <a:off x="1371600" y="3886200"/>
+            <a:ext cx="6400800" cy="1752600"/>
           </a:xfrm>
         </p:spPr>
         <p:txBody>
@@ -181,39 +194,93 @@
           <a:lstStyle>
             <a:lvl1pPr marL="0" indent="0" algn="ctr">
               <a:buNone/>
-              <a:defRPr sz="2400"/>
+              <a:defRPr>
+                <a:solidFill>
+                  <a:schemeClr val="tx1">
+                    <a:tint val="75000"/>
+                  </a:schemeClr>
+                </a:solidFill>
+              </a:defRPr>
             </a:lvl1pPr>
             <a:lvl2pPr marL="457200" indent="0" algn="ctr">
               <a:buNone/>
-              <a:defRPr sz="2000"/>
+              <a:defRPr>
+                <a:solidFill>
+                  <a:schemeClr val="tx1">
+                    <a:tint val="75000"/>
+                  </a:schemeClr>
+                </a:solidFill>
+              </a:defRPr>
             </a:lvl2pPr>
             <a:lvl3pPr marL="914400" indent="0" algn="ctr">
               <a:buNone/>
-              <a:defRPr sz="1800"/>
+              <a:defRPr>
+                <a:solidFill>
+                  <a:schemeClr val="tx1">
+                    <a:tint val="75000"/>
+                  </a:schemeClr>
+                </a:solidFill>
+              </a:defRPr>
             </a:lvl3pPr>
             <a:lvl4pPr marL="1371600" indent="0" algn="ctr">
               <a:buNone/>
-              <a:defRPr sz="1600"/>
+              <a:defRPr>
+                <a:solidFill>
+                  <a:schemeClr val="tx1">
+                    <a:tint val="75000"/>
+                  </a:schemeClr>
+                </a:solidFill>
+              </a:defRPr>
             </a:lvl4pPr>
             <a:lvl5pPr marL="1828800" indent="0" algn="ctr">
               <a:buNone/>
-              <a:defRPr sz="1600"/>
+              <a:defRPr>
+                <a:solidFill>
+                  <a:schemeClr val="tx1">
+                    <a:tint val="75000"/>
+                  </a:schemeClr>
+                </a:solidFill>
+              </a:defRPr>
             </a:lvl5pPr>
             <a:lvl6pPr marL="2286000" indent="0" algn="ctr">
               <a:buNone/>
-              <a:defRPr sz="1600"/>
+              <a:defRPr>
+                <a:solidFill>
+                  <a:schemeClr val="tx1">
+                    <a:tint val="75000"/>
+                  </a:schemeClr>
+                </a:solidFill>
+              </a:defRPr>
             </a:lvl6pPr>
             <a:lvl7pPr marL="2743200" indent="0" algn="ctr">
               <a:buNone/>
-              <a:defRPr sz="1600"/>
+              <a:defRPr>
+                <a:solidFill>
+                  <a:schemeClr val="tx1">
+                    <a:tint val="75000"/>
+                  </a:schemeClr>
+                </a:solidFill>
+              </a:defRPr>
             </a:lvl7pPr>
             <a:lvl8pPr marL="3200400" indent="0" algn="ctr">
               <a:buNone/>
-              <a:defRPr sz="1600"/>
+              <a:defRPr>
+                <a:solidFill>
+                  <a:schemeClr val="tx1">
+                    <a:tint val="75000"/>
+                  </a:schemeClr>
+                </a:solidFill>
+              </a:defRPr>
             </a:lvl8pPr>
             <a:lvl9pPr marL="3657600" indent="0" algn="ctr">
               <a:buNone/>
-              <a:defRPr sz="1600"/>
+              <a:defRPr>
+                <a:solidFill>
+                  <a:schemeClr val="tx1">
+                    <a:tint val="75000"/>
+                  </a:schemeClr>
+                </a:solidFill>
+              </a:defRPr>
             </a:lvl9pPr>
           </a:lstStyle>
           <a:p>
@@ -239,9 +306,10 @@
           <a:bodyPr/>
           <a:lstStyle/>
           <a:p>
-            <a:fld id="{06CA98C9-B594-47E7-B974-218B63804069}" type="datetimeFigureOut">
+            <a:fld id="{1D8BD707-D9CF-40AE-B4C6-C98DA3205C09}" type="datetimeFigureOut">
               <a:rPr lang="en-US" smtClean="0"/>
-              <a:t>5/23/2025</a:t>
+              <a:pPr/>
+              <a:t>5/22/2026</a:t>
             </a:fld>
             <a:endParaRPr lang="en-US"/>
           </a:p>
@@ -281,8 +349,9 @@
           <a:bodyPr/>
           <a:lstStyle/>
           <a:p>
-            <a:fld id="{A699832D-4A27-4D9A-A452-8124649BEEA9}" type="slidenum">
+            <a:fld id="{B6F15528-21DE-4FAA-801E-634DDDAF4B2B}" type="slidenum">
               <a:rPr lang="en-US" smtClean="0"/>
+              <a:pPr/>
               <a:t>‹#›</a:t>
             </a:fld>
             <a:endParaRPr lang="en-US"/>
@@ -290,11 +359,6 @@
         </p:txBody>
       </p:sp>
     </p:spTree>
-    <p:extLst>
-      <p:ext uri="{BB962C8B-B14F-4D97-AF65-F5344CB8AC3E}">
-        <p14:creationId xmlns:p14="http://schemas.microsoft.com/office/powerpoint/2010/main" val="3472845017"/>
-      </p:ext>
-    </p:extLst>
   </p:cSld>
   <p:clrMapOvr>
     <a:masterClrMapping/>
@@ -359,7 +423,7 @@
             <a:pPr lvl="0"/>
             <a:r>
               <a:rPr lang="en-US"/>
-              <a:t>Edit Master text styles</a:t>
+              <a:t>Click to edit Master text styles</a:t>
             </a:r>
           </a:p>
           <a:p>
@@ -407,9 +471,10 @@
           <a:bodyPr/>
           <a:lstStyle/>
           <a:p>
-            <a:fld id="{06CA98C9-B594-47E7-B974-218B63804069}" type="datetimeFigureOut">
+            <a:fld id="{1D8BD707-D9CF-40AE-B4C6-C98DA3205C09}" type="datetimeFigureOut">
               <a:rPr lang="en-US" smtClean="0"/>
-              <a:t>5/23/2025</a:t>
+              <a:pPr/>
+              <a:t>5/22/2026</a:t>
             </a:fld>
             <a:endParaRPr lang="en-US"/>
           </a:p>
@@ -449,8 +514,9 @@
           <a:bodyPr/>
           <a:lstStyle/>
           <a:p>
-            <a:fld id="{A699832D-4A27-4D9A-A452-8124649BEEA9}" type="slidenum">
+            <a:fld id="{B6F15528-21DE-4FAA-801E-634DDDAF4B2B}" type="slidenum">
               <a:rPr lang="en-US" smtClean="0"/>
+              <a:pPr/>
               <a:t>‹#›</a:t>
             </a:fld>
             <a:endParaRPr lang="en-US"/>
@@ -458,11 +524,6 @@
         </p:txBody>
       </p:sp>
     </p:spTree>
-    <p:extLst>
-      <p:ext uri="{BB962C8B-B14F-4D97-AF65-F5344CB8AC3E}">
-        <p14:creationId xmlns:p14="http://schemas.microsoft.com/office/powerpoint/2010/main" val="4005342311"/>
-      </p:ext>
-    </p:extLst>
   </p:cSld>
   <p:clrMapOvr>
     <a:masterClrMapping/>
@@ -499,8 +560,8 @@
         </p:nvSpPr>
         <p:spPr>
           <a:xfrm>
-            <a:off x="8724900" y="365125"/>
-            <a:ext cx="2628900" cy="5811838"/>
+            <a:off x="6629400" y="274638"/>
+            <a:ext cx="2057400" cy="5851525"/>
           </a:xfrm>
         </p:spPr>
         <p:txBody>
@@ -526,8 +587,8 @@
         </p:nvSpPr>
         <p:spPr>
           <a:xfrm>
-            <a:off x="838200" y="365125"/>
-            <a:ext cx="7734300" cy="5811838"/>
+            <a:off x="457200" y="274638"/>
+            <a:ext cx="6019800" cy="5851525"/>
           </a:xfrm>
         </p:spPr>
         <p:txBody>
@@ -537,7 +598,7 @@
             <a:pPr lvl="0"/>
             <a:r>
               <a:rPr lang="en-US"/>
-              <a:t>Edit Master text styles</a:t>
+              <a:t>Click to edit Master text styles</a:t>
             </a:r>
           </a:p>
           <a:p>
@@ -585,9 +646,10 @@
           <a:bodyPr/>
           <a:lstStyle/>
           <a:p>
-            <a:fld id="{06CA98C9-B594-47E7-B974-218B63804069}" type="datetimeFigureOut">
+            <a:fld id="{1D8BD707-D9CF-40AE-B4C6-C98DA3205C09}" type="datetimeFigureOut">
               <a:rPr lang="en-US" smtClean="0"/>
-              <a:t>5/23/2025</a:t>
+              <a:pPr/>
+              <a:t>5/22/2026</a:t>
             </a:fld>
             <a:endParaRPr lang="en-US"/>
           </a:p>
@@ -627,8 +689,9 @@
           <a:bodyPr/>
           <a:lstStyle/>
           <a:p>
-            <a:fld id="{A699832D-4A27-4D9A-A452-8124649BEEA9}" type="slidenum">
+            <a:fld id="{B6F15528-21DE-4FAA-801E-634DDDAF4B2B}" type="slidenum">
               <a:rPr lang="en-US" smtClean="0"/>
+              <a:pPr/>
               <a:t>‹#›</a:t>
             </a:fld>
             <a:endParaRPr lang="en-US"/>
@@ -636,11 +699,6 @@
         </p:txBody>
       </p:sp>
     </p:spTree>
-    <p:extLst>
-      <p:ext uri="{BB962C8B-B14F-4D97-AF65-F5344CB8AC3E}">
-        <p14:creationId xmlns:p14="http://schemas.microsoft.com/office/powerpoint/2010/main" val="1733973822"/>
-      </p:ext>
-    </p:extLst>
   </p:cSld>
   <p:clrMapOvr>
     <a:masterClrMapping/>
@@ -705,7 +763,7 @@
             <a:pPr lvl="0"/>
             <a:r>
               <a:rPr lang="en-US"/>
-              <a:t>Edit Master text styles</a:t>
+              <a:t>Click to edit Master text styles</a:t>
             </a:r>
           </a:p>
           <a:p>
@@ -753,9 +811,10 @@
           <a:bodyPr/>
           <a:lstStyle/>
           <a:p>
-            <a:fld id="{06CA98C9-B594-47E7-B974-218B63804069}" type="datetimeFigureOut">
+            <a:fld id="{1D8BD707-D9CF-40AE-B4C6-C98DA3205C09}" type="datetimeFigureOut">
               <a:rPr lang="en-US" smtClean="0"/>
-              <a:t>5/23/2025</a:t>
+              <a:pPr/>
+              <a:t>5/22/2026</a:t>
             </a:fld>
             <a:endParaRPr lang="en-US"/>
           </a:p>
@@ -795,8 +854,9 @@
           <a:bodyPr/>
           <a:lstStyle/>
           <a:p>
-            <a:fld id="{A699832D-4A27-4D9A-A452-8124649BEEA9}" type="slidenum">
+            <a:fld id="{B6F15528-21DE-4FAA-801E-634DDDAF4B2B}" type="slidenum">
               <a:rPr lang="en-US" smtClean="0"/>
+              <a:pPr/>
               <a:t>‹#›</a:t>
             </a:fld>
             <a:endParaRPr lang="en-US"/>
@@ -804,11 +864,6 @@
         </p:txBody>
       </p:sp>
     </p:spTree>
-    <p:extLst>
-      <p:ext uri="{BB962C8B-B14F-4D97-AF65-F5344CB8AC3E}">
-        <p14:creationId xmlns:p14="http://schemas.microsoft.com/office/powerpoint/2010/main" val="3643208688"/>
-      </p:ext>
-    </p:extLst>
   </p:cSld>
   <p:clrMapOvr>
     <a:masterClrMapping/>
@@ -845,47 +900,47 @@
         </p:nvSpPr>
         <p:spPr>
           <a:xfrm>
-            <a:off x="831850" y="1709738"/>
-            <a:ext cx="10515600" cy="2852737"/>
+            <a:off x="722313" y="4406900"/>
+            <a:ext cx="7772400" cy="1362075"/>
           </a:xfrm>
         </p:spPr>
         <p:txBody>
+          <a:bodyPr anchor="t"/>
+          <a:lstStyle>
+            <a:lvl1pPr algn="l">
+              <a:defRPr sz="4000" b="1" cap="all"/>
+            </a:lvl1pPr>
+          </a:lstStyle>
+          <a:p>
+            <a:r>
+              <a:rPr lang="en-US"/>
+              <a:t>Click to edit Master title style</a:t>
+            </a:r>
+          </a:p>
+        </p:txBody>
+      </p:sp>
+      <p:sp>
+        <p:nvSpPr>
+          <p:cNvPr id="3" name="Text Placeholder 2"/>
+          <p:cNvSpPr>
+            <a:spLocks noGrp="1"/>
+          </p:cNvSpPr>
+          <p:nvPr>
+            <p:ph type="body" idx="1"/>
+          </p:nvPr>
+        </p:nvSpPr>
+        <p:spPr>
+          <a:xfrm>
+            <a:off x="722313" y="2906713"/>
+            <a:ext cx="7772400" cy="1500187"/>
+          </a:xfrm>
+        </p:spPr>
+        <p:txBody>
           <a:bodyPr anchor="b"/>
           <a:lstStyle>
-            <a:lvl1pPr>
-              <a:defRPr sz="6000"/>
-            </a:lvl1pPr>
-          </a:lstStyle>
-          <a:p>
-            <a:r>
-              <a:rPr lang="en-US"/>
-              <a:t>Click to edit Master title style</a:t>
-            </a:r>
-          </a:p>
-        </p:txBody>
-      </p:sp>
-      <p:sp>
-        <p:nvSpPr>
-          <p:cNvPr id="3" name="Text Placeholder 2"/>
-          <p:cNvSpPr>
-            <a:spLocks noGrp="1"/>
-          </p:cNvSpPr>
-          <p:nvPr>
-            <p:ph type="body" idx="1"/>
-          </p:nvPr>
-        </p:nvSpPr>
-        <p:spPr>
-          <a:xfrm>
-            <a:off x="831850" y="4589463"/>
-            <a:ext cx="10515600" cy="1500187"/>
-          </a:xfrm>
-        </p:spPr>
-        <p:txBody>
-          <a:bodyPr/>
-          <a:lstStyle>
             <a:lvl1pPr marL="0" indent="0">
               <a:buNone/>
-              <a:defRPr sz="2400">
+              <a:defRPr sz="2000">
                 <a:solidFill>
                   <a:schemeClr val="tx1">
                     <a:tint val="75000"/>
@@ -895,7 +950,7 @@
             </a:lvl1pPr>
             <a:lvl2pPr marL="457200" indent="0">
               <a:buNone/>
-              <a:defRPr sz="2000">
+              <a:defRPr sz="1800">
                 <a:solidFill>
                   <a:schemeClr val="tx1">
                     <a:tint val="75000"/>
@@ -905,7 +960,7 @@
             </a:lvl2pPr>
             <a:lvl3pPr marL="914400" indent="0">
               <a:buNone/>
-              <a:defRPr sz="1800">
+              <a:defRPr sz="1600">
                 <a:solidFill>
                   <a:schemeClr val="tx1">
                     <a:tint val="75000"/>
@@ -915,7 +970,7 @@
             </a:lvl3pPr>
             <a:lvl4pPr marL="1371600" indent="0">
               <a:buNone/>
-              <a:defRPr sz="1600">
+              <a:defRPr sz="1400">
                 <a:solidFill>
                   <a:schemeClr val="tx1">
                     <a:tint val="75000"/>
@@ -925,7 +980,7 @@
             </a:lvl4pPr>
             <a:lvl5pPr marL="1828800" indent="0">
               <a:buNone/>
-              <a:defRPr sz="1600">
+              <a:defRPr sz="1400">
                 <a:solidFill>
                   <a:schemeClr val="tx1">
                     <a:tint val="75000"/>
@@ -935,7 +990,7 @@
             </a:lvl5pPr>
             <a:lvl6pPr marL="2286000" indent="0">
               <a:buNone/>
-              <a:defRPr sz="1600">
+              <a:defRPr sz="1400">
                 <a:solidFill>
                   <a:schemeClr val="tx1">
                     <a:tint val="75000"/>
@@ -945,7 +1000,7 @@
             </a:lvl6pPr>
             <a:lvl7pPr marL="2743200" indent="0">
               <a:buNone/>
-              <a:defRPr sz="1600">
+              <a:defRPr sz="1400">
                 <a:solidFill>
                   <a:schemeClr val="tx1">
                     <a:tint val="75000"/>
@@ -955,7 +1010,7 @@
             </a:lvl7pPr>
             <a:lvl8pPr marL="3200400" indent="0">
               <a:buNone/>
-              <a:defRPr sz="1600">
+              <a:defRPr sz="1400">
                 <a:solidFill>
                   <a:schemeClr val="tx1">
                     <a:tint val="75000"/>
@@ -965,7 +1020,7 @@
             </a:lvl8pPr>
             <a:lvl9pPr marL="3657600" indent="0">
               <a:buNone/>
-              <a:defRPr sz="1600">
+              <a:defRPr sz="1400">
                 <a:solidFill>
                   <a:schemeClr val="tx1">
                     <a:tint val="75000"/>
@@ -978,7 +1033,7 @@
             <a:pPr lvl="0"/>
             <a:r>
               <a:rPr lang="en-US"/>
-              <a:t>Edit Master text styles</a:t>
+              <a:t>Click to edit Master text styles</a:t>
             </a:r>
           </a:p>
         </p:txBody>
@@ -998,9 +1053,10 @@
           <a:bodyPr/>
           <a:lstStyle/>
           <a:p>
-            <a:fld id="{06CA98C9-B594-47E7-B974-218B63804069}" type="datetimeFigureOut">
+            <a:fld id="{1D8BD707-D9CF-40AE-B4C6-C98DA3205C09}" type="datetimeFigureOut">
               <a:rPr lang="en-US" smtClean="0"/>
-              <a:t>5/23/2025</a:t>
+              <a:pPr/>
+              <a:t>5/22/2026</a:t>
             </a:fld>
             <a:endParaRPr lang="en-US"/>
           </a:p>
@@ -1040,8 +1096,9 @@
           <a:bodyPr/>
           <a:lstStyle/>
           <a:p>
-            <a:fld id="{A699832D-4A27-4D9A-A452-8124649BEEA9}" type="slidenum">
+            <a:fld id="{B6F15528-21DE-4FAA-801E-634DDDAF4B2B}" type="slidenum">
               <a:rPr lang="en-US" smtClean="0"/>
+              <a:pPr/>
               <a:t>‹#›</a:t>
             </a:fld>
             <a:endParaRPr lang="en-US"/>
@@ -1049,11 +1106,6 @@
         </p:txBody>
       </p:sp>
     </p:spTree>
-    <p:extLst>
-      <p:ext uri="{BB962C8B-B14F-4D97-AF65-F5344CB8AC3E}">
-        <p14:creationId xmlns:p14="http://schemas.microsoft.com/office/powerpoint/2010/main" val="2568504366"/>
-      </p:ext>
-    </p:extLst>
   </p:cSld>
   <p:clrMapOvr>
     <a:masterClrMapping/>
@@ -1112,18 +1164,46 @@
         </p:nvSpPr>
         <p:spPr>
           <a:xfrm>
-            <a:off x="838200" y="1825625"/>
-            <a:ext cx="5181600" cy="4351338"/>
+            <a:off x="457200" y="1600200"/>
+            <a:ext cx="4038600" cy="4525963"/>
           </a:xfrm>
         </p:spPr>
         <p:txBody>
           <a:bodyPr/>
-          <a:lstStyle/>
+          <a:lstStyle>
+            <a:lvl1pPr>
+              <a:defRPr sz="2800"/>
+            </a:lvl1pPr>
+            <a:lvl2pPr>
+              <a:defRPr sz="2400"/>
+            </a:lvl2pPr>
+            <a:lvl3pPr>
+              <a:defRPr sz="2000"/>
+            </a:lvl3pPr>
+            <a:lvl4pPr>
+              <a:defRPr sz="1800"/>
+            </a:lvl4pPr>
+            <a:lvl5pPr>
+              <a:defRPr sz="1800"/>
+            </a:lvl5pPr>
+            <a:lvl6pPr>
+              <a:defRPr sz="1800"/>
+            </a:lvl6pPr>
+            <a:lvl7pPr>
+              <a:defRPr sz="1800"/>
+            </a:lvl7pPr>
+            <a:lvl8pPr>
+              <a:defRPr sz="1800"/>
+            </a:lvl8pPr>
+            <a:lvl9pPr>
+              <a:defRPr sz="1800"/>
+            </a:lvl9pPr>
+          </a:lstStyle>
           <a:p>
             <a:pPr lvl="0"/>
             <a:r>
               <a:rPr lang="en-US"/>
-              <a:t>Edit Master text styles</a:t>
+              <a:t>Click to edit Master text styles</a:t>
             </a:r>
           </a:p>
           <a:p>
@@ -1168,18 +1248,46 @@
         </p:nvSpPr>
         <p:spPr>
           <a:xfrm>
-            <a:off x="6172200" y="1825625"/>
-            <a:ext cx="5181600" cy="4351338"/>
+            <a:off x="4648200" y="1600200"/>
+            <a:ext cx="4038600" cy="4525963"/>
           </a:xfrm>
         </p:spPr>
         <p:txBody>
           <a:bodyPr/>
-          <a:lstStyle/>
+          <a:lstStyle>
+            <a:lvl1pPr>
+              <a:defRPr sz="2800"/>
+            </a:lvl1pPr>
+            <a:lvl2pPr>
+              <a:defRPr sz="2400"/>
+            </a:lvl2pPr>
+            <a:lvl3pPr>
+              <a:defRPr sz="2000"/>
+            </a:lvl3pPr>
+            <a:lvl4pPr>
+              <a:defRPr sz="1800"/>
+            </a:lvl4pPr>
+            <a:lvl5pPr>
+              <a:defRPr sz="1800"/>
+            </a:lvl5pPr>
+            <a:lvl6pPr>
+              <a:defRPr sz="1800"/>
+            </a:lvl6pPr>
+            <a:lvl7pPr>
+              <a:defRPr sz="1800"/>
+            </a:lvl7pPr>
+            <a:lvl8pPr>
+              <a:defRPr sz="1800"/>
+            </a:lvl8pPr>
+            <a:lvl9pPr>
+              <a:defRPr sz="1800"/>
+            </a:lvl9pPr>
+          </a:lstStyle>
           <a:p>
             <a:pPr lvl="0"/>
             <a:r>
               <a:rPr lang="en-US"/>
-              <a:t>Edit Master text styles</a:t>
+              <a:t>Click to edit Master text styles</a:t>
             </a:r>
           </a:p>
           <a:p>
@@ -1227,9 +1335,10 @@
           <a:bodyPr/>
           <a:lstStyle/>
           <a:p>
-            <a:fld id="{06CA98C9-B594-47E7-B974-218B63804069}" type="datetimeFigureOut">
+            <a:fld id="{1D8BD707-D9CF-40AE-B4C6-C98DA3205C09}" type="datetimeFigureOut">
               <a:rPr lang="en-US" smtClean="0"/>
-              <a:t>5/23/2025</a:t>
+              <a:pPr/>
+              <a:t>5/22/2026</a:t>
             </a:fld>
             <a:endParaRPr lang="en-US"/>
           </a:p>
@@ -1269,8 +1378,9 @@
           <a:bodyPr/>
           <a:lstStyle/>
           <a:p>
-            <a:fld id="{A699832D-4A27-4D9A-A452-8124649BEEA9}" type="slidenum">
+            <a:fld id="{B6F15528-21DE-4FAA-801E-634DDDAF4B2B}" type="slidenum">
               <a:rPr lang="en-US" smtClean="0"/>
+              <a:pPr/>
               <a:t>‹#›</a:t>
             </a:fld>
             <a:endParaRPr lang="en-US"/>
@@ -1278,11 +1388,6 @@
         </p:txBody>
       </p:sp>
     </p:spTree>
-    <p:extLst>
-      <p:ext uri="{BB962C8B-B14F-4D97-AF65-F5344CB8AC3E}">
-        <p14:creationId xmlns:p14="http://schemas.microsoft.com/office/powerpoint/2010/main" val="2218308063"/>
-      </p:ext>
-    </p:extLst>
   </p:cSld>
   <p:clrMapOvr>
     <a:masterClrMapping/>
@@ -1317,37 +1422,36 @@
             <p:ph type="title"/>
           </p:nvPr>
         </p:nvSpPr>
+        <p:spPr/>
+        <p:txBody>
+          <a:bodyPr/>
+          <a:lstStyle>
+            <a:lvl1pPr>
+              <a:defRPr/>
+            </a:lvl1pPr>
+          </a:lstStyle>
+          <a:p>
+            <a:r>
+              <a:rPr lang="en-US"/>
+              <a:t>Click to edit Master title style</a:t>
+            </a:r>
+          </a:p>
+        </p:txBody>
+      </p:sp>
+      <p:sp>
+        <p:nvSpPr>
+          <p:cNvPr id="3" name="Text Placeholder 2"/>
+          <p:cNvSpPr>
+            <a:spLocks noGrp="1"/>
+          </p:cNvSpPr>
+          <p:nvPr>
+            <p:ph type="body" idx="1"/>
+          </p:nvPr>
+        </p:nvSpPr>
         <p:spPr>
           <a:xfrm>
-            <a:off x="839788" y="365125"/>
-            <a:ext cx="10515600" cy="1325563"/>
-          </a:xfrm>
-        </p:spPr>
-        <p:txBody>
-          <a:bodyPr/>
-          <a:lstStyle/>
-          <a:p>
-            <a:r>
-              <a:rPr lang="en-US"/>
-              <a:t>Click to edit Master title style</a:t>
-            </a:r>
-          </a:p>
-        </p:txBody>
-      </p:sp>
-      <p:sp>
-        <p:nvSpPr>
-          <p:cNvPr id="3" name="Text Placeholder 2"/>
-          <p:cNvSpPr>
-            <a:spLocks noGrp="1"/>
-          </p:cNvSpPr>
-          <p:nvPr>
-            <p:ph type="body" idx="1"/>
-          </p:nvPr>
-        </p:nvSpPr>
-        <p:spPr>
-          <a:xfrm>
-            <a:off x="839788" y="1681163"/>
-            <a:ext cx="5157787" cy="823912"/>
+            <a:off x="457200" y="1535113"/>
+            <a:ext cx="4040188" cy="639762"/>
           </a:xfrm>
         </p:spPr>
         <p:txBody>
@@ -1394,7 +1498,7 @@
             <a:pPr lvl="0"/>
             <a:r>
               <a:rPr lang="en-US"/>
-              <a:t>Edit Master text styles</a:t>
+              <a:t>Click to edit Master text styles</a:t>
             </a:r>
           </a:p>
         </p:txBody>
@@ -1411,18 +1515,46 @@
         </p:nvSpPr>
         <p:spPr>
           <a:xfrm>
-            <a:off x="839788" y="2505075"/>
-            <a:ext cx="5157787" cy="3684588"/>
+            <a:off x="457200" y="2174875"/>
+            <a:ext cx="4040188" cy="3951288"/>
           </a:xfrm>
         </p:spPr>
         <p:txBody>
           <a:bodyPr/>
-          <a:lstStyle/>
+          <a:lstStyle>
+            <a:lvl1pPr>
+              <a:defRPr sz="2400"/>
+            </a:lvl1pPr>
+            <a:lvl2pPr>
+              <a:defRPr sz="2000"/>
+            </a:lvl2pPr>
+            <a:lvl3pPr>
+              <a:defRPr sz="1800"/>
+            </a:lvl3pPr>
+            <a:lvl4pPr>
+              <a:defRPr sz="1600"/>
+            </a:lvl4pPr>
+            <a:lvl5pPr>
+              <a:defRPr sz="1600"/>
+            </a:lvl5pPr>
+            <a:lvl6pPr>
+              <a:defRPr sz="1600"/>
+            </a:lvl6pPr>
+            <a:lvl7pPr>
+              <a:defRPr sz="1600"/>
+            </a:lvl7pPr>
+            <a:lvl8pPr>
+              <a:defRPr sz="1600"/>
+            </a:lvl8pPr>
+            <a:lvl9pPr>
+              <a:defRPr sz="1600"/>
+            </a:lvl9pPr>
+          </a:lstStyle>
           <a:p>
             <a:pPr lvl="0"/>
             <a:r>
               <a:rPr lang="en-US"/>
-              <a:t>Edit Master text styles</a:t>
+              <a:t>Click to edit Master text styles</a:t>
             </a:r>
           </a:p>
           <a:p>
@@ -1467,8 +1599,8 @@
         </p:nvSpPr>
         <p:spPr>
           <a:xfrm>
-            <a:off x="6172200" y="1681163"/>
-            <a:ext cx="5183188" cy="823912"/>
+            <a:off x="4645025" y="1535113"/>
+            <a:ext cx="4041775" cy="639762"/>
           </a:xfrm>
         </p:spPr>
         <p:txBody>
@@ -1515,7 +1647,7 @@
             <a:pPr lvl="0"/>
             <a:r>
               <a:rPr lang="en-US"/>
-              <a:t>Edit Master text styles</a:t>
+              <a:t>Click to edit Master text styles</a:t>
             </a:r>
           </a:p>
         </p:txBody>
@@ -1532,18 +1664,46 @@
         </p:nvSpPr>
         <p:spPr>
           <a:xfrm>
-            <a:off x="6172200" y="2505075"/>
-            <a:ext cx="5183188" cy="3684588"/>
+            <a:off x="4645025" y="2174875"/>
+            <a:ext cx="4041775" cy="3951288"/>
           </a:xfrm>
         </p:spPr>
         <p:txBody>
           <a:bodyPr/>
-          <a:lstStyle/>
+          <a:lstStyle>
+            <a:lvl1pPr>
+              <a:defRPr sz="2400"/>
+            </a:lvl1pPr>
+            <a:lvl2pPr>
+              <a:defRPr sz="2000"/>
+            </a:lvl2pPr>
+            <a:lvl3pPr>
+              <a:defRPr sz="1800"/>
+            </a:lvl3pPr>
+            <a:lvl4pPr>
+              <a:defRPr sz="1600"/>
+            </a:lvl4pPr>
+            <a:lvl5pPr>
+              <a:defRPr sz="1600"/>
+            </a:lvl5pPr>
+            <a:lvl6pPr>
+              <a:defRPr sz="1600"/>
+            </a:lvl6pPr>
+            <a:lvl7pPr>
+              <a:defRPr sz="1600"/>
+            </a:lvl7pPr>
+            <a:lvl8pPr>
+              <a:defRPr sz="1600"/>
+            </a:lvl8pPr>
+            <a:lvl9pPr>
+              <a:defRPr sz="1600"/>
+            </a:lvl9pPr>
+          </a:lstStyle>
           <a:p>
             <a:pPr lvl="0"/>
             <a:r>
               <a:rPr lang="en-US"/>
-              <a:t>Edit Master text styles</a:t>
+              <a:t>Click to edit Master text styles</a:t>
             </a:r>
           </a:p>
           <a:p>
@@ -1591,9 +1751,10 @@
           <a:bodyPr/>
           <a:lstStyle/>
           <a:p>
-            <a:fld id="{06CA98C9-B594-47E7-B974-218B63804069}" type="datetimeFigureOut">
+            <a:fld id="{1D8BD707-D9CF-40AE-B4C6-C98DA3205C09}" type="datetimeFigureOut">
               <a:rPr lang="en-US" smtClean="0"/>
-              <a:t>5/23/2025</a:t>
+              <a:pPr/>
+              <a:t>5/22/2026</a:t>
             </a:fld>
             <a:endParaRPr lang="en-US"/>
           </a:p>
@@ -1633,8 +1794,9 @@
           <a:bodyPr/>
           <a:lstStyle/>
           <a:p>
-            <a:fld id="{A699832D-4A27-4D9A-A452-8124649BEEA9}" type="slidenum">
+            <a:fld id="{B6F15528-21DE-4FAA-801E-634DDDAF4B2B}" type="slidenum">
               <a:rPr lang="en-US" smtClean="0"/>
+              <a:pPr/>
               <a:t>‹#›</a:t>
             </a:fld>
             <a:endParaRPr lang="en-US"/>
@@ -1642,11 +1804,6 @@
         </p:txBody>
       </p:sp>
     </p:spTree>
-    <p:extLst>
-      <p:ext uri="{BB962C8B-B14F-4D97-AF65-F5344CB8AC3E}">
-        <p14:creationId xmlns:p14="http://schemas.microsoft.com/office/powerpoint/2010/main" val="3982768018"/>
-      </p:ext>
-    </p:extLst>
   </p:cSld>
   <p:clrMapOvr>
     <a:masterClrMapping/>
@@ -1708,9 +1865,10 @@
           <a:bodyPr/>
           <a:lstStyle/>
           <a:p>
-            <a:fld id="{06CA98C9-B594-47E7-B974-218B63804069}" type="datetimeFigureOut">
+            <a:fld id="{1D8BD707-D9CF-40AE-B4C6-C98DA3205C09}" type="datetimeFigureOut">
               <a:rPr lang="en-US" smtClean="0"/>
-              <a:t>5/23/2025</a:t>
+              <a:pPr/>
+              <a:t>5/22/2026</a:t>
             </a:fld>
             <a:endParaRPr lang="en-US"/>
           </a:p>
@@ -1750,8 +1908,9 @@
           <a:bodyPr/>
           <a:lstStyle/>
           <a:p>
-            <a:fld id="{A699832D-4A27-4D9A-A452-8124649BEEA9}" type="slidenum">
+            <a:fld id="{B6F15528-21DE-4FAA-801E-634DDDAF4B2B}" type="slidenum">
               <a:rPr lang="en-US" smtClean="0"/>
+              <a:pPr/>
               <a:t>‹#›</a:t>
             </a:fld>
             <a:endParaRPr lang="en-US"/>
@@ -1759,11 +1918,6 @@
         </p:txBody>
       </p:sp>
     </p:spTree>
-    <p:extLst>
-      <p:ext uri="{BB962C8B-B14F-4D97-AF65-F5344CB8AC3E}">
-        <p14:creationId xmlns:p14="http://schemas.microsoft.com/office/powerpoint/2010/main" val="1114689949"/>
-      </p:ext>
-    </p:extLst>
   </p:cSld>
   <p:clrMapOvr>
     <a:masterClrMapping/>
@@ -1803,9 +1957,10 @@
           <a:bodyPr/>
           <a:lstStyle/>
           <a:p>
-            <a:fld id="{06CA98C9-B594-47E7-B974-218B63804069}" type="datetimeFigureOut">
+            <a:fld id="{1D8BD707-D9CF-40AE-B4C6-C98DA3205C09}" type="datetimeFigureOut">
               <a:rPr lang="en-US" smtClean="0"/>
-              <a:t>5/23/2025</a:t>
+              <a:pPr/>
+              <a:t>5/22/2026</a:t>
             </a:fld>
             <a:endParaRPr lang="en-US"/>
           </a:p>
@@ -1845,8 +2000,9 @@
           <a:bodyPr/>
           <a:lstStyle/>
           <a:p>
-            <a:fld id="{A699832D-4A27-4D9A-A452-8124649BEEA9}" type="slidenum">
+            <a:fld id="{B6F15528-21DE-4FAA-801E-634DDDAF4B2B}" type="slidenum">
               <a:rPr lang="en-US" smtClean="0"/>
+              <a:pPr/>
               <a:t>‹#›</a:t>
             </a:fld>
             <a:endParaRPr lang="en-US"/>
@@ -1854,11 +2010,6 @@
         </p:txBody>
       </p:sp>
     </p:spTree>
-    <p:extLst>
-      <p:ext uri="{BB962C8B-B14F-4D97-AF65-F5344CB8AC3E}">
-        <p14:creationId xmlns:p14="http://schemas.microsoft.com/office/powerpoint/2010/main" val="3957622657"/>
-      </p:ext>
-    </p:extLst>
   </p:cSld>
   <p:clrMapOvr>
     <a:masterClrMapping/>
@@ -1895,15 +2046,15 @@
         </p:nvSpPr>
         <p:spPr>
           <a:xfrm>
-            <a:off x="839788" y="457200"/>
-            <a:ext cx="3932237" cy="1600200"/>
+            <a:off x="457200" y="273050"/>
+            <a:ext cx="3008313" cy="1162050"/>
           </a:xfrm>
         </p:spPr>
         <p:txBody>
           <a:bodyPr anchor="b"/>
           <a:lstStyle>
-            <a:lvl1pPr>
-              <a:defRPr sz="3200"/>
+            <a:lvl1pPr algn="l">
+              <a:defRPr sz="2000" b="1"/>
             </a:lvl1pPr>
           </a:lstStyle>
           <a:p>
@@ -1926,8 +2077,8 @@
         </p:nvSpPr>
         <p:spPr>
           <a:xfrm>
-            <a:off x="5183188" y="987425"/>
-            <a:ext cx="6172200" cy="4873625"/>
+            <a:off x="3575050" y="273050"/>
+            <a:ext cx="5111750" cy="5853113"/>
           </a:xfrm>
         </p:spPr>
         <p:txBody>
@@ -1965,7 +2116,7 @@
             <a:pPr lvl="0"/>
             <a:r>
               <a:rPr lang="en-US"/>
-              <a:t>Edit Master text styles</a:t>
+              <a:t>Click to edit Master text styles</a:t>
             </a:r>
           </a:p>
           <a:p>
@@ -2010,8 +2161,8 @@
         </p:nvSpPr>
         <p:spPr>
           <a:xfrm>
-            <a:off x="839788" y="2057400"/>
-            <a:ext cx="3932237" cy="3811588"/>
+            <a:off x="457200" y="1435100"/>
+            <a:ext cx="3008313" cy="4691063"/>
           </a:xfrm>
         </p:spPr>
         <p:txBody>
@@ -2019,46 +2170,46 @@
           <a:lstStyle>
             <a:lvl1pPr marL="0" indent="0">
               <a:buNone/>
-              <a:defRPr sz="1600"/>
+              <a:defRPr sz="1400"/>
             </a:lvl1pPr>
             <a:lvl2pPr marL="457200" indent="0">
               <a:buNone/>
-              <a:defRPr sz="1400"/>
+              <a:defRPr sz="1200"/>
             </a:lvl2pPr>
             <a:lvl3pPr marL="914400" indent="0">
               <a:buNone/>
-              <a:defRPr sz="1200"/>
+              <a:defRPr sz="1000"/>
             </a:lvl3pPr>
             <a:lvl4pPr marL="1371600" indent="0">
               <a:buNone/>
-              <a:defRPr sz="1000"/>
+              <a:defRPr sz="900"/>
             </a:lvl4pPr>
             <a:lvl5pPr marL="1828800" indent="0">
               <a:buNone/>
-              <a:defRPr sz="1000"/>
+              <a:defRPr sz="900"/>
             </a:lvl5pPr>
             <a:lvl6pPr marL="2286000" indent="0">
               <a:buNone/>
-              <a:defRPr sz="1000"/>
+              <a:defRPr sz="900"/>
             </a:lvl6pPr>
             <a:lvl7pPr marL="2743200" indent="0">
               <a:buNone/>
-              <a:defRPr sz="1000"/>
+              <a:defRPr sz="900"/>
             </a:lvl7pPr>
             <a:lvl8pPr marL="3200400" indent="0">
               <a:buNone/>
-              <a:defRPr sz="1000"/>
+              <a:defRPr sz="900"/>
             </a:lvl8pPr>
             <a:lvl9pPr marL="3657600" indent="0">
               <a:buNone/>
-              <a:defRPr sz="1000"/>
+              <a:defRPr sz="900"/>
             </a:lvl9pPr>
           </a:lstStyle>
           <a:p>
             <a:pPr lvl="0"/>
             <a:r>
               <a:rPr lang="en-US"/>
-              <a:t>Edit Master text styles</a:t>
+              <a:t>Click to edit Master text styles</a:t>
             </a:r>
           </a:p>
         </p:txBody>
@@ -2078,9 +2229,10 @@
           <a:bodyPr/>
           <a:lstStyle/>
           <a:p>
-            <a:fld id="{06CA98C9-B594-47E7-B974-218B63804069}" type="datetimeFigureOut">
+            <a:fld id="{1D8BD707-D9CF-40AE-B4C6-C98DA3205C09}" type="datetimeFigureOut">
               <a:rPr lang="en-US" smtClean="0"/>
-              <a:t>5/23/2025</a:t>
+              <a:pPr/>
+              <a:t>5/22/2026</a:t>
             </a:fld>
             <a:endParaRPr lang="en-US"/>
           </a:p>
@@ -2120,8 +2272,9 @@
           <a:bodyPr/>
           <a:lstStyle/>
           <a:p>
-            <a:fld id="{A699832D-4A27-4D9A-A452-8124649BEEA9}" type="slidenum">
+            <a:fld id="{B6F15528-21DE-4FAA-801E-634DDDAF4B2B}" type="slidenum">
               <a:rPr lang="en-US" smtClean="0"/>
+              <a:pPr/>
               <a:t>‹#›</a:t>
             </a:fld>
             <a:endParaRPr lang="en-US"/>
@@ -2129,11 +2282,6 @@
         </p:txBody>
       </p:sp>
     </p:spTree>
-    <p:extLst>
-      <p:ext uri="{BB962C8B-B14F-4D97-AF65-F5344CB8AC3E}">
-        <p14:creationId xmlns:p14="http://schemas.microsoft.com/office/powerpoint/2010/main" val="646649598"/>
-      </p:ext>
-    </p:extLst>
   </p:cSld>
   <p:clrMapOvr>
     <a:masterClrMapping/>
@@ -2170,15 +2318,15 @@
         </p:nvSpPr>
         <p:spPr>
           <a:xfrm>
-            <a:off x="839788" y="457200"/>
-            <a:ext cx="3932237" cy="1600200"/>
+            <a:off x="1792288" y="4800600"/>
+            <a:ext cx="5486400" cy="566738"/>
           </a:xfrm>
         </p:spPr>
         <p:txBody>
           <a:bodyPr anchor="b"/>
           <a:lstStyle>
-            <a:lvl1pPr>
-              <a:defRPr sz="3200"/>
+            <a:lvl1pPr algn="l">
+              <a:defRPr sz="2000" b="1"/>
             </a:lvl1pPr>
           </a:lstStyle>
           <a:p>
@@ -2201,8 +2349,8 @@
         </p:nvSpPr>
         <p:spPr>
           <a:xfrm>
-            <a:off x="5183188" y="987425"/>
-            <a:ext cx="6172200" cy="4873625"/>
+            <a:off x="1792288" y="612775"/>
+            <a:ext cx="5486400" cy="4114800"/>
           </a:xfrm>
         </p:spPr>
         <p:txBody>
@@ -2262,8 +2410,8 @@
         </p:nvSpPr>
         <p:spPr>
           <a:xfrm>
-            <a:off x="839788" y="2057400"/>
-            <a:ext cx="3932237" cy="3811588"/>
+            <a:off x="1792288" y="5367338"/>
+            <a:ext cx="5486400" cy="804862"/>
           </a:xfrm>
         </p:spPr>
         <p:txBody>
@@ -2271,46 +2419,46 @@
           <a:lstStyle>
             <a:lvl1pPr marL="0" indent="0">
               <a:buNone/>
-              <a:defRPr sz="1600"/>
+              <a:defRPr sz="1400"/>
             </a:lvl1pPr>
             <a:lvl2pPr marL="457200" indent="0">
               <a:buNone/>
-              <a:defRPr sz="1400"/>
+              <a:defRPr sz="1200"/>
             </a:lvl2pPr>
             <a:lvl3pPr marL="914400" indent="0">
               <a:buNone/>
-              <a:defRPr sz="1200"/>
+              <a:defRPr sz="1000"/>
             </a:lvl3pPr>
             <a:lvl4pPr marL="1371600" indent="0">
               <a:buNone/>
-              <a:defRPr sz="1000"/>
+              <a:defRPr sz="900"/>
             </a:lvl4pPr>
             <a:lvl5pPr marL="1828800" indent="0">
               <a:buNone/>
-              <a:defRPr sz="1000"/>
+              <a:defRPr sz="900"/>
             </a:lvl5pPr>
             <a:lvl6pPr marL="2286000" indent="0">
               <a:buNone/>
-              <a:defRPr sz="1000"/>
+              <a:defRPr sz="900"/>
             </a:lvl6pPr>
             <a:lvl7pPr marL="2743200" indent="0">
               <a:buNone/>
-              <a:defRPr sz="1000"/>
+              <a:defRPr sz="900"/>
             </a:lvl7pPr>
             <a:lvl8pPr marL="3200400" indent="0">
               <a:buNone/>
-              <a:defRPr sz="1000"/>
+              <a:defRPr sz="900"/>
             </a:lvl8pPr>
             <a:lvl9pPr marL="3657600" indent="0">
               <a:buNone/>
-              <a:defRPr sz="1000"/>
+              <a:defRPr sz="900"/>
             </a:lvl9pPr>
           </a:lstStyle>
           <a:p>
             <a:pPr lvl="0"/>
             <a:r>
               <a:rPr lang="en-US"/>
-              <a:t>Edit Master text styles</a:t>
+              <a:t>Click to edit Master text styles</a:t>
             </a:r>
           </a:p>
         </p:txBody>
@@ -2330,9 +2478,10 @@
           <a:bodyPr/>
           <a:lstStyle/>
           <a:p>
-            <a:fld id="{06CA98C9-B594-47E7-B974-218B63804069}" type="datetimeFigureOut">
+            <a:fld id="{1D8BD707-D9CF-40AE-B4C6-C98DA3205C09}" type="datetimeFigureOut">
               <a:rPr lang="en-US" smtClean="0"/>
-              <a:t>5/23/2025</a:t>
+              <a:pPr/>
+              <a:t>5/22/2026</a:t>
             </a:fld>
             <a:endParaRPr lang="en-US"/>
           </a:p>
@@ -2372,8 +2521,9 @@
           <a:bodyPr/>
           <a:lstStyle/>
           <a:p>
-            <a:fld id="{A699832D-4A27-4D9A-A452-8124649BEEA9}" type="slidenum">
+            <a:fld id="{B6F15528-21DE-4FAA-801E-634DDDAF4B2B}" type="slidenum">
               <a:rPr lang="en-US" smtClean="0"/>
+              <a:pPr/>
               <a:t>‹#›</a:t>
             </a:fld>
             <a:endParaRPr lang="en-US"/>
@@ -2381,11 +2531,6 @@
         </p:txBody>
       </p:sp>
     </p:spTree>
-    <p:extLst>
-      <p:ext uri="{BB962C8B-B14F-4D97-AF65-F5344CB8AC3E}">
-        <p14:creationId xmlns:p14="http://schemas.microsoft.com/office/powerpoint/2010/main" val="2564777119"/>
-      </p:ext>
-    </p:extLst>
   </p:cSld>
   <p:clrMapOvr>
     <a:masterClrMapping/>
@@ -2397,12 +2542,9 @@
 <p:sldMaster xmlns:a="http://schemas.openxmlformats.org/drawingml/2006/main" xmlns:r="http://schemas.openxmlformats.org/officeDocument/2006/relationships" xmlns:p="http://schemas.openxmlformats.org/presentationml/2006/main">
   <p:cSld>
     <p:bg>
-      <p:bgPr>
-        <a:solidFill>
-          <a:srgbClr val="1CE421"/>
-        </a:solidFill>
-        <a:effectLst/>
-      </p:bgPr>
+      <p:bgRef idx="1001">
+        <a:schemeClr val="bg1"/>
+      </p:bgRef>
     </p:bg>
     <p:spTree>
       <p:nvGrpSpPr>
@@ -2430,8 +2572,8 @@
         </p:nvSpPr>
         <p:spPr>
           <a:xfrm>
-            <a:off x="838200" y="365125"/>
-            <a:ext cx="10515600" cy="1325563"/>
+            <a:off x="457200" y="274638"/>
+            <a:ext cx="8229600" cy="1143000"/>
           </a:xfrm>
           <a:prstGeom prst="rect">
             <a:avLst/>
@@ -2462,8 +2604,8 @@
         </p:nvSpPr>
         <p:spPr>
           <a:xfrm>
-            <a:off x="838200" y="1825625"/>
-            <a:ext cx="10515600" cy="4351338"/>
+            <a:off x="457200" y="1600200"/>
+            <a:ext cx="8229600" cy="4525963"/>
           </a:xfrm>
           <a:prstGeom prst="rect">
             <a:avLst/>
@@ -2478,7 +2620,7 @@
             <a:pPr lvl="0"/>
             <a:r>
               <a:rPr lang="en-US"/>
-              <a:t>Edit Master text styles</a:t>
+              <a:t>Click to edit Master text styles</a:t>
             </a:r>
           </a:p>
           <a:p>
@@ -2523,8 +2665,8 @@
         </p:nvSpPr>
         <p:spPr>
           <a:xfrm>
-            <a:off x="838200" y="6356350"/>
-            <a:ext cx="2743200" cy="365125"/>
+            <a:off x="457200" y="6356350"/>
+            <a:ext cx="2133600" cy="365125"/>
           </a:xfrm>
           <a:prstGeom prst="rect">
             <a:avLst/>
@@ -2544,9 +2686,10 @@
             </a:lvl1pPr>
           </a:lstStyle>
           <a:p>
-            <a:fld id="{06CA98C9-B594-47E7-B974-218B63804069}" type="datetimeFigureOut">
+            <a:fld id="{1D8BD707-D9CF-40AE-B4C6-C98DA3205C09}" type="datetimeFigureOut">
               <a:rPr lang="en-US" smtClean="0"/>
-              <a:t>5/23/2025</a:t>
+              <a:pPr/>
+              <a:t>5/22/2026</a:t>
             </a:fld>
             <a:endParaRPr lang="en-US"/>
           </a:p>
@@ -2564,8 +2707,8 @@
         </p:nvSpPr>
         <p:spPr>
           <a:xfrm>
-            <a:off x="4038600" y="6356350"/>
-            <a:ext cx="4114800" cy="365125"/>
+            <a:off x="3124200" y="6356350"/>
+            <a:ext cx="2895600" cy="365125"/>
           </a:xfrm>
           <a:prstGeom prst="rect">
             <a:avLst/>
@@ -2601,8 +2744,8 @@
         </p:nvSpPr>
         <p:spPr>
           <a:xfrm>
-            <a:off x="8610600" y="6356350"/>
-            <a:ext cx="2743200" cy="365125"/>
+            <a:off x="6553200" y="6356350"/>
+            <a:ext cx="2133600" cy="365125"/>
           </a:xfrm>
           <a:prstGeom prst="rect">
             <a:avLst/>
@@ -2622,8 +2765,9 @@
             </a:lvl1pPr>
           </a:lstStyle>
           <a:p>
-            <a:fld id="{A699832D-4A27-4D9A-A452-8124649BEEA9}" type="slidenum">
+            <a:fld id="{B6F15528-21DE-4FAA-801E-634DDDAF4B2B}" type="slidenum">
               <a:rPr lang="en-US" smtClean="0"/>
+              <a:pPr/>
               <a:t>‹#›</a:t>
             </a:fld>
             <a:endParaRPr lang="en-US"/>
@@ -2631,32 +2775,24 @@
         </p:txBody>
       </p:sp>
     </p:spTree>
-    <p:extLst>
-      <p:ext uri="{BB962C8B-B14F-4D97-AF65-F5344CB8AC3E}">
-        <p14:creationId xmlns:p14="http://schemas.microsoft.com/office/powerpoint/2010/main" val="3834085582"/>
-      </p:ext>
-    </p:extLst>
   </p:cSld>
   <p:clrMap bg1="lt1" tx1="dk1" bg2="lt2" tx2="dk2" accent1="accent1" accent2="accent2" accent3="accent3" accent4="accent4" accent5="accent5" accent6="accent6" hlink="hlink" folHlink="folHlink"/>
   <p:sldLayoutIdLst>
-    <p:sldLayoutId id="2147483661" r:id="rId1"/>
-    <p:sldLayoutId id="2147483662" r:id="rId2"/>
-    <p:sldLayoutId id="2147483663" r:id="rId3"/>
-    <p:sldLayoutId id="2147483664" r:id="rId4"/>
-    <p:sldLayoutId id="2147483665" r:id="rId5"/>
-    <p:sldLayoutId id="2147483666" r:id="rId6"/>
-    <p:sldLayoutId id="2147483667" r:id="rId7"/>
-    <p:sldLayoutId id="2147483668" r:id="rId8"/>
-    <p:sldLayoutId id="2147483669" r:id="rId9"/>
-    <p:sldLayoutId id="2147483670" r:id="rId10"/>
-    <p:sldLayoutId id="2147483671" r:id="rId11"/>
+    <p:sldLayoutId id="2147483649" r:id="rId1"/>
+    <p:sldLayoutId id="2147483650" r:id="rId2"/>
+    <p:sldLayoutId id="2147483651" r:id="rId3"/>
+    <p:sldLayoutId id="2147483652" r:id="rId4"/>
+    <p:sldLayoutId id="2147483653" r:id="rId5"/>
+    <p:sldLayoutId id="2147483654" r:id="rId6"/>
+    <p:sldLayoutId id="2147483655" r:id="rId7"/>
+    <p:sldLayoutId id="2147483656" r:id="rId8"/>
+    <p:sldLayoutId id="2147483657" r:id="rId9"/>
+    <p:sldLayoutId id="2147483658" r:id="rId10"/>
+    <p:sldLayoutId id="2147483659" r:id="rId11"/>
   </p:sldLayoutIdLst>
   <p:txStyles>
     <p:titleStyle>
-      <a:lvl1pPr algn="l" defTabSz="914400" rtl="0" eaLnBrk="1" latinLnBrk="0" hangingPunct="1">
-        <a:lnSpc>
-          <a:spcPct val="90000"/>
-        </a:lnSpc>
+      <a:lvl1pPr algn="ctr" defTabSz="914400" rtl="0" eaLnBrk="1" latinLnBrk="0" hangingPunct="1">
         <a:spcBef>
           <a:spcPct val="0"/>
         </a:spcBef>
@@ -2672,15 +2808,27 @@
       </a:lvl1pPr>
     </p:titleStyle>
     <p:bodyStyle>
-      <a:lvl1pPr marL="228600" indent="-228600" algn="l" defTabSz="914400" rtl="0" eaLnBrk="1" latinLnBrk="0" hangingPunct="1">
-        <a:lnSpc>
-          <a:spcPct val="90000"/>
-        </a:lnSpc>
+      <a:lvl1pPr marL="342900" indent="-342900" algn="l" defTabSz="914400" rtl="0" eaLnBrk="1" latinLnBrk="0" hangingPunct="1">
         <a:spcBef>
-          <a:spcPts val="1000"/>
+          <a:spcPct val="20000"/>
         </a:spcBef>
-        <a:buFont typeface="Arial" panose="020B0604020202020204" pitchFamily="34" charset="0"/>
+        <a:buFont typeface="Arial" pitchFamily="34" charset="0"/>
         <a:buChar char="•"/>
+        <a:defRPr sz="3200" kern="1200">
+          <a:solidFill>
+            <a:schemeClr val="tx1"/>
+          </a:solidFill>
+          <a:latin typeface="+mn-lt"/>
+          <a:ea typeface="+mn-ea"/>
+          <a:cs typeface="+mn-cs"/>
+        </a:defRPr>
+      </a:lvl1pPr>
+      <a:lvl2pPr marL="742950" indent="-285750" algn="l" defTabSz="914400" rtl="0" eaLnBrk="1" latinLnBrk="0" hangingPunct="1">
+        <a:spcBef>
+          <a:spcPct val="20000"/>
+        </a:spcBef>
+        <a:buFont typeface="Arial" pitchFamily="34" charset="0"/>
+        <a:buChar char="–"/>
         <a:defRPr sz="2800" kern="1200">
           <a:solidFill>
             <a:schemeClr val="tx1"/>
@@ -2689,15 +2837,12 @@
           <a:ea typeface="+mn-ea"/>
           <a:cs typeface="+mn-cs"/>
         </a:defRPr>
-      </a:lvl1pPr>
-      <a:lvl2pPr marL="685800" indent="-228600" algn="l" defTabSz="914400" rtl="0" eaLnBrk="1" latinLnBrk="0" hangingPunct="1">
-        <a:lnSpc>
-          <a:spcPct val="90000"/>
-        </a:lnSpc>
+      </a:lvl2pPr>
+      <a:lvl3pPr marL="1143000" indent="-228600" algn="l" defTabSz="914400" rtl="0" eaLnBrk="1" latinLnBrk="0" hangingPunct="1">
         <a:spcBef>
-          <a:spcPts val="500"/>
+          <a:spcPct val="20000"/>
         </a:spcBef>
-        <a:buFont typeface="Arial" panose="020B0604020202020204" pitchFamily="34" charset="0"/>
+        <a:buFont typeface="Arial" pitchFamily="34" charset="0"/>
         <a:buChar char="•"/>
         <a:defRPr sz="2400" kern="1200">
           <a:solidFill>
@@ -2707,15 +2852,42 @@
           <a:ea typeface="+mn-ea"/>
           <a:cs typeface="+mn-cs"/>
         </a:defRPr>
-      </a:lvl2pPr>
-      <a:lvl3pPr marL="1143000" indent="-228600" algn="l" defTabSz="914400" rtl="0" eaLnBrk="1" latinLnBrk="0" hangingPunct="1">
-        <a:lnSpc>
-          <a:spcPct val="90000"/>
-        </a:lnSpc>
+      </a:lvl3pPr>
+      <a:lvl4pPr marL="1600200" indent="-228600" algn="l" defTabSz="914400" rtl="0" eaLnBrk="1" latinLnBrk="0" hangingPunct="1">
         <a:spcBef>
-          <a:spcPts val="500"/>
+          <a:spcPct val="20000"/>
         </a:spcBef>
-        <a:buFont typeface="Arial" panose="020B0604020202020204" pitchFamily="34" charset="0"/>
+        <a:buFont typeface="Arial" pitchFamily="34" charset="0"/>
+        <a:buChar char="–"/>
+        <a:defRPr sz="2000" kern="1200">
+          <a:solidFill>
+            <a:schemeClr val="tx1"/>
+          </a:solidFill>
+          <a:latin typeface="+mn-lt"/>
+          <a:ea typeface="+mn-ea"/>
+          <a:cs typeface="+mn-cs"/>
+        </a:defRPr>
+      </a:lvl4pPr>
+      <a:lvl5pPr marL="2057400" indent="-228600" algn="l" defTabSz="914400" rtl="0" eaLnBrk="1" latinLnBrk="0" hangingPunct="1">
+        <a:spcBef>
+          <a:spcPct val="20000"/>
+        </a:spcBef>
+        <a:buFont typeface="Arial" pitchFamily="34" charset="0"/>
+        <a:buChar char="»"/>
+        <a:defRPr sz="2000" kern="1200">
+          <a:solidFill>
+            <a:schemeClr val="tx1"/>
+          </a:solidFill>
+          <a:latin typeface="+mn-lt"/>
+          <a:ea typeface="+mn-ea"/>
+          <a:cs typeface="+mn-cs"/>
+        </a:defRPr>
+      </a:lvl5pPr>
+      <a:lvl6pPr marL="2514600" indent="-228600" algn="l" defTabSz="914400" rtl="0" eaLnBrk="1" latinLnBrk="0" hangingPunct="1">
+        <a:spcBef>
+          <a:spcPct val="20000"/>
+        </a:spcBef>
+        <a:buFont typeface="Arial" pitchFamily="34" charset="0"/>
         <a:buChar char="•"/>
         <a:defRPr sz="2000" kern="1200">
           <a:solidFill>
@@ -2725,71 +2897,14 @@
           <a:ea typeface="+mn-ea"/>
           <a:cs typeface="+mn-cs"/>
         </a:defRPr>
-      </a:lvl3pPr>
-      <a:lvl4pPr marL="1600200" indent="-228600" algn="l" defTabSz="914400" rtl="0" eaLnBrk="1" latinLnBrk="0" hangingPunct="1">
-        <a:lnSpc>
-          <a:spcPct val="90000"/>
-        </a:lnSpc>
-        <a:spcBef>
-          <a:spcPts val="500"/>
-        </a:spcBef>
-        <a:buFont typeface="Arial" panose="020B0604020202020204" pitchFamily="34" charset="0"/>
-        <a:buChar char="•"/>
-        <a:defRPr sz="1800" kern="1200">
-          <a:solidFill>
-            <a:schemeClr val="tx1"/>
-          </a:solidFill>
-          <a:latin typeface="+mn-lt"/>
-          <a:ea typeface="+mn-ea"/>
-          <a:cs typeface="+mn-cs"/>
-        </a:defRPr>
-      </a:lvl4pPr>
-      <a:lvl5pPr marL="2057400" indent="-228600" algn="l" defTabSz="914400" rtl="0" eaLnBrk="1" latinLnBrk="0" hangingPunct="1">
-        <a:lnSpc>
-          <a:spcPct val="90000"/>
-        </a:lnSpc>
-        <a:spcBef>
-          <a:spcPts val="500"/>
-        </a:spcBef>
-        <a:buFont typeface="Arial" panose="020B0604020202020204" pitchFamily="34" charset="0"/>
-        <a:buChar char="•"/>
-        <a:defRPr sz="1800" kern="1200">
-          <a:solidFill>
-            <a:schemeClr val="tx1"/>
-          </a:solidFill>
-          <a:latin typeface="+mn-lt"/>
-          <a:ea typeface="+mn-ea"/>
-          <a:cs typeface="+mn-cs"/>
-        </a:defRPr>
-      </a:lvl5pPr>
-      <a:lvl6pPr marL="2514600" indent="-228600" algn="l" defTabSz="914400" rtl="0" eaLnBrk="1" latinLnBrk="0" hangingPunct="1">
-        <a:lnSpc>
-          <a:spcPct val="90000"/>
-        </a:lnSpc>
-        <a:spcBef>
-          <a:spcPts val="500"/>
-        </a:spcBef>
-        <a:buFont typeface="Arial" panose="020B0604020202020204" pitchFamily="34" charset="0"/>
-        <a:buChar char="•"/>
-        <a:defRPr sz="1800" kern="1200">
-          <a:solidFill>
-            <a:schemeClr val="tx1"/>
-          </a:solidFill>
-          <a:latin typeface="+mn-lt"/>
-          <a:ea typeface="+mn-ea"/>
-          <a:cs typeface="+mn-cs"/>
-        </a:defRPr>
       </a:lvl6pPr>
       <a:lvl7pPr marL="2971800" indent="-228600" algn="l" defTabSz="914400" rtl="0" eaLnBrk="1" latinLnBrk="0" hangingPunct="1">
-        <a:lnSpc>
-          <a:spcPct val="90000"/>
-        </a:lnSpc>
         <a:spcBef>
-          <a:spcPts val="500"/>
+          <a:spcPct val="20000"/>
         </a:spcBef>
-        <a:buFont typeface="Arial" panose="020B0604020202020204" pitchFamily="34" charset="0"/>
+        <a:buFont typeface="Arial" pitchFamily="34" charset="0"/>
         <a:buChar char="•"/>
-        <a:defRPr sz="1800" kern="1200">
+        <a:defRPr sz="2000" kern="1200">
           <a:solidFill>
             <a:schemeClr val="tx1"/>
           </a:solidFill>
@@ -2799,15 +2914,12 @@
         </a:defRPr>
       </a:lvl7pPr>
       <a:lvl8pPr marL="3429000" indent="-228600" algn="l" defTabSz="914400" rtl="0" eaLnBrk="1" latinLnBrk="0" hangingPunct="1">
-        <a:lnSpc>
-          <a:spcPct val="90000"/>
-        </a:lnSpc>
         <a:spcBef>
-          <a:spcPts val="500"/>
+          <a:spcPct val="20000"/>
         </a:spcBef>
-        <a:buFont typeface="Arial" panose="020B0604020202020204" pitchFamily="34" charset="0"/>
+        <a:buFont typeface="Arial" pitchFamily="34" charset="0"/>
         <a:buChar char="•"/>
-        <a:defRPr sz="1800" kern="1200">
+        <a:defRPr sz="2000" kern="1200">
           <a:solidFill>
             <a:schemeClr val="tx1"/>
           </a:solidFill>
@@ -2817,15 +2929,12 @@
         </a:defRPr>
       </a:lvl8pPr>
       <a:lvl9pPr marL="3886200" indent="-228600" algn="l" defTabSz="914400" rtl="0" eaLnBrk="1" latinLnBrk="0" hangingPunct="1">
-        <a:lnSpc>
-          <a:spcPct val="90000"/>
-        </a:lnSpc>
         <a:spcBef>
-          <a:spcPts val="500"/>
+          <a:spcPct val="20000"/>
         </a:spcBef>
-        <a:buFont typeface="Arial" panose="020B0604020202020204" pitchFamily="34" charset="0"/>
+        <a:buFont typeface="Arial" pitchFamily="34" charset="0"/>
         <a:buChar char="•"/>
-        <a:defRPr sz="1800" kern="1200">
+        <a:defRPr sz="2000" kern="1200">
           <a:solidFill>
             <a:schemeClr val="tx1"/>
           </a:solidFill>
@@ -2937,17 +3046,15 @@
 <file path=ppt/slides/slide1.xml><?xml version="1.0" encoding="utf-8"?>
 <p:sld xmlns:a="http://schemas.openxmlformats.org/drawingml/2006/main" xmlns:r="http://schemas.openxmlformats.org/officeDocument/2006/relationships" xmlns:p="http://schemas.openxmlformats.org/presentationml/2006/main">
   <p:cSld>
-    <p:bg>
-      <p:bgPr>
-        <a:solidFill>
-          <a:srgbClr val="0070C0"/>
-        </a:solidFill>
-        <a:effectLst/>
-      </p:bgPr>
-    </p:bg>
     <p:spTree>
       <p:nvGrpSpPr>
-        <p:cNvPr id="1" name=""/>
+        <p:cNvPr id="1" name="">
+          <a:extLst>
+            <a:ext uri="{FF2B5EF4-FFF2-40B4-BE49-F238E27FC236}">
+              <a16:creationId xmlns:a16="http://schemas.microsoft.com/office/drawing/2014/main" id="{B7344D95-EE7B-96E6-747B-7E116D4A1CC5}"/>
+            </a:ext>
+          </a:extLst>
+        </p:cNvPr>
         <p:cNvGrpSpPr/>
         <p:nvPr/>
       </p:nvGrpSpPr>
@@ -2959,861 +3066,64 @@
           <a:chExt cx="0" cy="0"/>
         </a:xfrm>
       </p:grpSpPr>
-      <p:grpSp>
-        <p:nvGrpSpPr>
-          <p:cNvPr id="2" name="Group 1">
+      <p:sp>
+        <p:nvSpPr>
+          <p:cNvPr id="11" name="Rectangle 10">
             <a:extLst>
               <a:ext uri="{FF2B5EF4-FFF2-40B4-BE49-F238E27FC236}">
-                <a16:creationId xmlns:a16="http://schemas.microsoft.com/office/drawing/2014/main" id="{B336EAF9-48B5-AC8A-19A6-05EAD01885FF}"/>
+                <a16:creationId xmlns:a16="http://schemas.microsoft.com/office/drawing/2014/main" id="{15BE49B4-04A8-EDD6-A60B-4AC57762C1C6}"/>
               </a:ext>
             </a:extLst>
           </p:cNvPr>
-          <p:cNvGrpSpPr/>
+          <p:cNvSpPr/>
           <p:nvPr/>
-        </p:nvGrpSpPr>
-        <p:grpSpPr>
+        </p:nvSpPr>
+        <p:spPr>
           <a:xfrm>
-            <a:off x="0" y="5218042"/>
-            <a:ext cx="12192000" cy="1158162"/>
-            <a:chOff x="0" y="5218047"/>
-            <a:chExt cx="12192000" cy="1155920"/>
+            <a:off x="0" y="2005"/>
+            <a:ext cx="18440400" cy="10287000"/>
           </a:xfrm>
-        </p:grpSpPr>
-        <p:sp>
-          <p:nvSpPr>
-            <p:cNvPr id="3" name="Rectangle 2">
-              <a:extLst>
-                <a:ext uri="{FF2B5EF4-FFF2-40B4-BE49-F238E27FC236}">
-                  <a16:creationId xmlns:a16="http://schemas.microsoft.com/office/drawing/2014/main" id="{A8BD71DB-98E8-162F-FF71-89713FE68AA1}"/>
-                </a:ext>
-              </a:extLst>
-            </p:cNvPr>
-            <p:cNvSpPr/>
-            <p:nvPr/>
-          </p:nvSpPr>
-          <p:spPr>
-            <a:xfrm>
-              <a:off x="0" y="6179864"/>
-              <a:ext cx="12192000" cy="194103"/>
-            </a:xfrm>
-            <a:prstGeom prst="rect">
-              <a:avLst/>
-            </a:prstGeom>
-            <a:solidFill>
-              <a:srgbClr val="EAC954"/>
-            </a:solidFill>
-            <a:effectLst>
-              <a:outerShdw blurRad="50800" dist="38100" dir="5400000" algn="t" rotWithShape="0">
-                <a:prstClr val="black">
-                  <a:alpha val="26000"/>
-                </a:prstClr>
-              </a:outerShdw>
-            </a:effectLst>
-          </p:spPr>
-          <p:style>
-            <a:lnRef idx="0">
-              <a:schemeClr val="accent5"/>
-            </a:lnRef>
-            <a:fillRef idx="3">
-              <a:schemeClr val="accent5"/>
-            </a:fillRef>
-            <a:effectRef idx="3">
-              <a:schemeClr val="accent5"/>
-            </a:effectRef>
-            <a:fontRef idx="minor">
-              <a:schemeClr val="lt1"/>
-            </a:fontRef>
-          </p:style>
-          <p:txBody>
-            <a:bodyPr rtlCol="0" anchor="ctr"/>
-            <a:lstStyle/>
-            <a:p>
-              <a:pPr marL="0" marR="0" lvl="0" indent="0" algn="ctr" defTabSz="914400" rtl="0" eaLnBrk="1" fontAlgn="auto" latinLnBrk="0" hangingPunct="1">
-                <a:lnSpc>
-                  <a:spcPct val="100000"/>
-                </a:lnSpc>
-                <a:spcBef>
-                  <a:spcPts val="0"/>
-                </a:spcBef>
-                <a:spcAft>
-                  <a:spcPts val="0"/>
-                </a:spcAft>
-                <a:buClrTx/>
-                <a:buSzTx/>
-                <a:buFontTx/>
-                <a:buNone/>
-                <a:tabLst/>
-                <a:defRPr/>
-              </a:pPr>
-              <a:endParaRPr kumimoji="0" lang="en-US" sz="1200" b="0" i="0" u="none" strike="noStrike" kern="1200" cap="none" spc="0" normalizeH="0" baseline="0" noProof="0">
-                <a:ln>
-                  <a:noFill/>
-                </a:ln>
-                <a:solidFill>
-                  <a:prstClr val="white"/>
-                </a:solidFill>
-                <a:effectLst/>
-                <a:uLnTx/>
-                <a:uFillTx/>
-                <a:latin typeface="Calibri" panose="020F0502020204030204"/>
-                <a:ea typeface="+mn-ea"/>
-                <a:cs typeface="+mn-cs"/>
-              </a:endParaRPr>
-            </a:p>
-          </p:txBody>
-        </p:sp>
-        <p:pic>
-          <p:nvPicPr>
-            <p:cNvPr id="5" name="Picture 4">
-              <a:extLst>
-                <a:ext uri="{FF2B5EF4-FFF2-40B4-BE49-F238E27FC236}">
-                  <a16:creationId xmlns:a16="http://schemas.microsoft.com/office/drawing/2014/main" id="{7630FCA9-EABA-CD1B-03C0-0B3D31983561}"/>
-                </a:ext>
-              </a:extLst>
-            </p:cNvPr>
-            <p:cNvPicPr>
-              <a:picLocks noChangeAspect="1"/>
-            </p:cNvPicPr>
-            <p:nvPr/>
-          </p:nvPicPr>
-          <p:blipFill>
-            <a:blip r:embed="rId2" cstate="print">
-              <a:extLst>
-                <a:ext uri="{28A0092B-C50C-407E-A947-70E740481C1C}">
-                  <a14:useLocalDpi xmlns:a14="http://schemas.microsoft.com/office/drawing/2010/main" val="0"/>
-                </a:ext>
-              </a:extLst>
-            </a:blip>
-            <a:stretch>
-              <a:fillRect/>
-            </a:stretch>
-          </p:blipFill>
-          <p:spPr>
-            <a:xfrm>
-              <a:off x="0" y="5268902"/>
-              <a:ext cx="12192000" cy="993242"/>
-            </a:xfrm>
-            <a:prstGeom prst="rect">
-              <a:avLst/>
-            </a:prstGeom>
-            <a:effectLst/>
-          </p:spPr>
-        </p:pic>
-        <p:grpSp>
-          <p:nvGrpSpPr>
-            <p:cNvPr id="16" name="Group 15" hidden="1">
-              <a:extLst>
-                <a:ext uri="{FF2B5EF4-FFF2-40B4-BE49-F238E27FC236}">
-                  <a16:creationId xmlns:a16="http://schemas.microsoft.com/office/drawing/2014/main" id="{4CAA1D4A-FF23-AED3-8794-9D578817701B}"/>
-                </a:ext>
-              </a:extLst>
-            </p:cNvPr>
-            <p:cNvGrpSpPr/>
-            <p:nvPr/>
-          </p:nvGrpSpPr>
-          <p:grpSpPr>
-            <a:xfrm>
-              <a:off x="388375" y="5218047"/>
-              <a:ext cx="1693820" cy="961816"/>
-              <a:chOff x="441439" y="5085942"/>
-              <a:chExt cx="1663180" cy="1032954"/>
-            </a:xfrm>
-          </p:grpSpPr>
-          <p:sp>
-            <p:nvSpPr>
-              <p:cNvPr id="18" name="TextBox 17">
-                <a:extLst>
-                  <a:ext uri="{FF2B5EF4-FFF2-40B4-BE49-F238E27FC236}">
-                    <a16:creationId xmlns:a16="http://schemas.microsoft.com/office/drawing/2014/main" id="{8B9D67E3-602F-7098-2259-2BA3EC4C4B01}"/>
-                  </a:ext>
-                </a:extLst>
-              </p:cNvPr>
-              <p:cNvSpPr txBox="1"/>
-              <p:nvPr/>
-            </p:nvSpPr>
-            <p:spPr>
-              <a:xfrm rot="21384788">
-                <a:off x="522407" y="5085942"/>
-                <a:ext cx="1455174" cy="584775"/>
-              </a:xfrm>
-              <a:prstGeom prst="rect">
-                <a:avLst/>
-              </a:prstGeom>
-              <a:noFill/>
-            </p:spPr>
-            <p:txBody>
-              <a:bodyPr wrap="square" rtlCol="0">
-                <a:spAutoFit/>
-              </a:bodyPr>
-              <a:lstStyle/>
-              <a:p>
-                <a:pPr marL="0" marR="0" lvl="0" indent="0" algn="l" defTabSz="914400" rtl="0" eaLnBrk="1" fontAlgn="auto" latinLnBrk="0" hangingPunct="1">
-                  <a:lnSpc>
-                    <a:spcPct val="100000"/>
-                  </a:lnSpc>
-                  <a:spcBef>
-                    <a:spcPts val="0"/>
-                  </a:spcBef>
-                  <a:spcAft>
-                    <a:spcPts val="0"/>
-                  </a:spcAft>
-                  <a:buClrTx/>
-                  <a:buSzTx/>
-                  <a:buFontTx/>
-                  <a:buNone/>
-                  <a:tabLst/>
-                  <a:defRPr/>
-                </a:pPr>
-                <a:r>
-                  <a:rPr kumimoji="0" lang="en-US" sz="3200" b="0" i="0" u="none" strike="noStrike" kern="1200" cap="none" spc="0" normalizeH="0" baseline="0" noProof="0" dirty="0">
-                    <a:ln>
-                      <a:noFill/>
-                    </a:ln>
-                    <a:solidFill>
-                      <a:prstClr val="white"/>
-                    </a:solidFill>
-                    <a:effectLst/>
-                    <a:uLnTx/>
-                    <a:uFillTx/>
-                    <a:latin typeface="Freestyle Script" panose="030804020302050B0404" pitchFamily="66" charset="0"/>
-                    <a:ea typeface="+mn-ea"/>
-                    <a:cs typeface="Dreaming Outloud Script Pro" panose="020F0502020204030204" pitchFamily="66" charset="0"/>
-                  </a:rPr>
-                  <a:t>Graduating</a:t>
-                </a:r>
-                <a:endParaRPr kumimoji="0" lang="en-US" sz="1600" b="0" i="0" u="none" strike="noStrike" kern="1200" cap="none" spc="0" normalizeH="0" baseline="0" noProof="0" dirty="0">
-                  <a:ln>
-                    <a:noFill/>
-                  </a:ln>
-                  <a:solidFill>
-                    <a:prstClr val="white"/>
-                  </a:solidFill>
-                  <a:effectLst/>
-                  <a:uLnTx/>
-                  <a:uFillTx/>
-                  <a:latin typeface="Freestyle Script" panose="030804020302050B0404" pitchFamily="66" charset="0"/>
-                  <a:ea typeface="+mn-ea"/>
-                  <a:cs typeface="Dreaming Outloud Script Pro" panose="020F0502020204030204" pitchFamily="66" charset="0"/>
-                </a:endParaRPr>
-              </a:p>
-            </p:txBody>
-          </p:sp>
-          <p:sp>
-            <p:nvSpPr>
-              <p:cNvPr id="22" name="TextBox 21">
-                <a:extLst>
-                  <a:ext uri="{FF2B5EF4-FFF2-40B4-BE49-F238E27FC236}">
-                    <a16:creationId xmlns:a16="http://schemas.microsoft.com/office/drawing/2014/main" id="{67D4CF51-1B76-8186-E6B4-0EBAF7C4B6B1}"/>
-                  </a:ext>
-                </a:extLst>
-              </p:cNvPr>
-              <p:cNvSpPr txBox="1"/>
-              <p:nvPr/>
-            </p:nvSpPr>
-            <p:spPr>
-              <a:xfrm>
-                <a:off x="441439" y="5420992"/>
-                <a:ext cx="1488907" cy="492443"/>
-              </a:xfrm>
-              <a:prstGeom prst="rect">
-                <a:avLst/>
-              </a:prstGeom>
-              <a:noFill/>
-            </p:spPr>
-            <p:txBody>
-              <a:bodyPr wrap="square" rtlCol="0">
-                <a:spAutoFit/>
-              </a:bodyPr>
-              <a:lstStyle/>
-              <a:p>
-                <a:pPr marL="0" marR="0" lvl="0" indent="0" algn="l" defTabSz="914400" rtl="0" eaLnBrk="1" fontAlgn="auto" latinLnBrk="0" hangingPunct="1">
-                  <a:lnSpc>
-                    <a:spcPct val="100000"/>
-                  </a:lnSpc>
-                  <a:spcBef>
-                    <a:spcPts val="0"/>
-                  </a:spcBef>
-                  <a:spcAft>
-                    <a:spcPts val="0"/>
-                  </a:spcAft>
-                  <a:buClrTx/>
-                  <a:buSzTx/>
-                  <a:buFontTx/>
-                  <a:buNone/>
-                  <a:tabLst/>
-                  <a:defRPr/>
-                </a:pPr>
-                <a:r>
-                  <a:rPr kumimoji="0" lang="en-US" sz="2600" b="0" i="0" u="none" strike="noStrike" kern="1200" cap="none" spc="0" normalizeH="0" baseline="0" noProof="0" dirty="0">
-                    <a:ln>
-                      <a:noFill/>
-                    </a:ln>
-                    <a:solidFill>
-                      <a:prstClr val="white"/>
-                    </a:solidFill>
-                    <a:effectLst/>
-                    <a:uLnTx/>
-                    <a:uFillTx/>
-                    <a:latin typeface="Calibri" panose="020F0502020204030204"/>
-                    <a:ea typeface="+mn-ea"/>
-                    <a:cs typeface="+mn-cs"/>
-                  </a:rPr>
-                  <a:t>CLASS OF</a:t>
-                </a:r>
-              </a:p>
-            </p:txBody>
-          </p:sp>
-          <p:sp>
-            <p:nvSpPr>
-              <p:cNvPr id="23" name="TextBox 22">
-                <a:extLst>
-                  <a:ext uri="{FF2B5EF4-FFF2-40B4-BE49-F238E27FC236}">
-                    <a16:creationId xmlns:a16="http://schemas.microsoft.com/office/drawing/2014/main" id="{3259B4D0-357A-426E-0AC6-B5634C8D3AA5}"/>
-                  </a:ext>
-                </a:extLst>
-              </p:cNvPr>
-              <p:cNvSpPr txBox="1"/>
-              <p:nvPr/>
-            </p:nvSpPr>
-            <p:spPr>
-              <a:xfrm>
-                <a:off x="506426" y="5718786"/>
-                <a:ext cx="1598193" cy="400110"/>
-              </a:xfrm>
-              <a:prstGeom prst="rect">
-                <a:avLst/>
-              </a:prstGeom>
-              <a:noFill/>
-            </p:spPr>
-            <p:txBody>
-              <a:bodyPr wrap="square" rtlCol="0">
-                <a:spAutoFit/>
-              </a:bodyPr>
-              <a:lstStyle/>
-              <a:p>
-                <a:pPr marL="0" marR="0" lvl="0" indent="0" algn="l" defTabSz="914400" rtl="0" eaLnBrk="1" fontAlgn="auto" latinLnBrk="0" hangingPunct="1">
-                  <a:lnSpc>
-                    <a:spcPct val="100000"/>
-                  </a:lnSpc>
-                  <a:spcBef>
-                    <a:spcPts val="0"/>
-                  </a:spcBef>
-                  <a:spcAft>
-                    <a:spcPts val="0"/>
-                  </a:spcAft>
-                  <a:buClrTx/>
-                  <a:buSzTx/>
-                  <a:buFontTx/>
-                  <a:buNone/>
-                  <a:tabLst/>
-                  <a:defRPr/>
-                </a:pPr>
-                <a:r>
-                  <a:rPr kumimoji="0" lang="en-US" sz="2000" b="1" i="0" u="none" strike="noStrike" kern="1200" cap="none" spc="0" normalizeH="0" baseline="0" noProof="0" dirty="0">
-                    <a:ln>
-                      <a:noFill/>
-                    </a:ln>
-                    <a:solidFill>
-                      <a:prstClr val="white"/>
-                    </a:solidFill>
-                    <a:effectLst/>
-                    <a:uLnTx/>
-                    <a:uFillTx/>
-                    <a:latin typeface="Calibri" panose="020F0502020204030204"/>
-                    <a:ea typeface="+mn-ea"/>
-                    <a:cs typeface="+mn-cs"/>
-                  </a:rPr>
-                  <a:t>2023-2024</a:t>
-                </a:r>
-              </a:p>
-            </p:txBody>
-          </p:sp>
-        </p:grpSp>
-        <p:pic>
-          <p:nvPicPr>
-            <p:cNvPr id="17" name="Picture 16" descr="A picture containing ax&#10;&#10;Description automatically generated" hidden="1">
-              <a:extLst>
-                <a:ext uri="{FF2B5EF4-FFF2-40B4-BE49-F238E27FC236}">
-                  <a16:creationId xmlns:a16="http://schemas.microsoft.com/office/drawing/2014/main" id="{DFBB3726-35E1-38B8-2183-DD4A9F887925}"/>
-                </a:ext>
-              </a:extLst>
-            </p:cNvPr>
-            <p:cNvPicPr>
-              <a:picLocks noChangeAspect="1"/>
-            </p:cNvPicPr>
-            <p:nvPr/>
-          </p:nvPicPr>
-          <p:blipFill>
-            <a:blip r:embed="rId3" cstate="print">
-              <a:extLst>
-                <a:ext uri="{28A0092B-C50C-407E-A947-70E740481C1C}">
-                  <a14:useLocalDpi xmlns:a14="http://schemas.microsoft.com/office/drawing/2010/main" val="0"/>
-                </a:ext>
-              </a:extLst>
-            </a:blip>
-            <a:stretch>
-              <a:fillRect/>
-            </a:stretch>
-          </p:blipFill>
-          <p:spPr>
-            <a:xfrm>
-              <a:off x="11013644" y="5461171"/>
-              <a:ext cx="608004" cy="713131"/>
-            </a:xfrm>
-            <a:prstGeom prst="rect">
-              <a:avLst/>
-            </a:prstGeom>
-          </p:spPr>
-        </p:pic>
-        <p:sp>
-          <p:nvSpPr>
-            <p:cNvPr id="14" name="Name">
-              <a:extLst>
-                <a:ext uri="{FF2B5EF4-FFF2-40B4-BE49-F238E27FC236}">
-                  <a16:creationId xmlns:a16="http://schemas.microsoft.com/office/drawing/2014/main" id="{47CD8718-3F34-CD0C-2FEF-5088032DF50A}"/>
-                </a:ext>
-              </a:extLst>
-            </p:cNvPr>
-            <p:cNvSpPr txBox="1"/>
-            <p:nvPr/>
-          </p:nvSpPr>
-          <p:spPr>
-            <a:xfrm>
-              <a:off x="581290" y="5570987"/>
-              <a:ext cx="11124038" cy="460771"/>
-            </a:xfrm>
-            <a:prstGeom prst="rect">
-              <a:avLst/>
-            </a:prstGeom>
+          <a:prstGeom prst="rect">
+            <a:avLst/>
+          </a:prstGeom>
+          <a:solidFill>
+            <a:srgbClr val="6EBD00"/>
+          </a:solidFill>
+          <a:ln>
             <a:noFill/>
-          </p:spPr>
-          <p:txBody>
-            <a:bodyPr wrap="square" rtlCol="0">
-              <a:spAutoFit/>
-            </a:bodyPr>
-            <a:lstStyle/>
-            <a:p>
-              <a:pPr marL="0" marR="0" lvl="0" indent="0" algn="ctr" defTabSz="914400" rtl="0" eaLnBrk="1" fontAlgn="auto" latinLnBrk="0" hangingPunct="1">
-                <a:lnSpc>
-                  <a:spcPct val="100000"/>
-                </a:lnSpc>
-                <a:spcBef>
-                  <a:spcPts val="0"/>
-                </a:spcBef>
-                <a:spcAft>
-                  <a:spcPts val="0"/>
-                </a:spcAft>
-                <a:buClrTx/>
-                <a:buSzTx/>
-                <a:buFontTx/>
-                <a:buNone/>
-                <a:tabLst/>
-                <a:defRPr/>
-              </a:pPr>
-              <a:r>
-                <a:rPr kumimoji="0" lang="en-US" sz="2400" b="1" i="0" u="none" strike="noStrike" kern="1200" cap="none" spc="0" normalizeH="0" baseline="0" noProof="0" dirty="0">
-                  <a:ln>
-                    <a:noFill/>
-                  </a:ln>
-                  <a:solidFill>
-                    <a:prstClr val="white"/>
-                  </a:solidFill>
-                  <a:effectLst>
-                    <a:outerShdw blurRad="50800" dist="50800" dir="5400000" algn="ctr" rotWithShape="0">
-                      <a:prstClr val="black">
-                        <a:alpha val="52000"/>
-                      </a:prstClr>
-                    </a:outerShdw>
-                  </a:effectLst>
-                  <a:uLnTx/>
-                  <a:uFillTx/>
-                  <a:latin typeface="Tahoma" panose="020B0604030504040204" pitchFamily="34" charset="0"/>
-                  <a:ea typeface="Tahoma" panose="020B0604030504040204" pitchFamily="34" charset="0"/>
-                  <a:cs typeface="Tahoma" panose="020B0604030504040204" pitchFamily="34" charset="0"/>
-                </a:rPr>
-                <a:t>.</a:t>
-              </a:r>
-            </a:p>
-          </p:txBody>
-        </p:sp>
-      </p:grpSp>
-      <p:grpSp>
-        <p:nvGrpSpPr>
-          <p:cNvPr id="40" name="Group 39" hidden="1">
+          </a:ln>
+        </p:spPr>
+        <p:style>
+          <a:lnRef idx="2">
+            <a:schemeClr val="accent1">
+              <a:shade val="15000"/>
+            </a:schemeClr>
+          </a:lnRef>
+          <a:fillRef idx="1">
+            <a:schemeClr val="accent1"/>
+          </a:fillRef>
+          <a:effectRef idx="0">
+            <a:schemeClr val="accent1"/>
+          </a:effectRef>
+          <a:fontRef idx="minor">
+            <a:schemeClr val="lt1"/>
+          </a:fontRef>
+        </p:style>
+        <p:txBody>
+          <a:bodyPr rtlCol="0" anchor="ctr"/>
+          <a:lstStyle/>
+          <a:p>
+            <a:pPr algn="ctr"/>
+            <a:endParaRPr lang="en-TH"/>
+          </a:p>
+        </p:txBody>
+      </p:sp>
+      <p:pic>
+        <p:nvPicPr>
+          <p:cNvPr id="13" name="Picture 12">
             <a:extLst>
               <a:ext uri="{FF2B5EF4-FFF2-40B4-BE49-F238E27FC236}">
-                <a16:creationId xmlns:a16="http://schemas.microsoft.com/office/drawing/2014/main" id="{179184C7-6AA5-9638-2692-50E6B2F8D47D}"/>
-              </a:ext>
-            </a:extLst>
-          </p:cNvPr>
-          <p:cNvGrpSpPr/>
-          <p:nvPr/>
-        </p:nvGrpSpPr>
-        <p:grpSpPr>
-          <a:xfrm>
-            <a:off x="-9314" y="5220290"/>
-            <a:ext cx="2113281" cy="1155920"/>
-            <a:chOff x="383951" y="2620494"/>
-            <a:chExt cx="2113281" cy="1155920"/>
-          </a:xfrm>
-        </p:grpSpPr>
-        <p:sp>
-          <p:nvSpPr>
-            <p:cNvPr id="30" name="Rectangle 29">
-              <a:extLst>
-                <a:ext uri="{FF2B5EF4-FFF2-40B4-BE49-F238E27FC236}">
-                  <a16:creationId xmlns:a16="http://schemas.microsoft.com/office/drawing/2014/main" id="{6F4044AE-86FB-DF5D-0062-06D573045038}"/>
-                </a:ext>
-              </a:extLst>
-            </p:cNvPr>
-            <p:cNvSpPr/>
-            <p:nvPr/>
-          </p:nvSpPr>
-          <p:spPr>
-            <a:xfrm>
-              <a:off x="383951" y="3582311"/>
-              <a:ext cx="2113281" cy="194103"/>
-            </a:xfrm>
-            <a:prstGeom prst="rect">
-              <a:avLst/>
-            </a:prstGeom>
-            <a:solidFill>
-              <a:srgbClr val="EAC954"/>
-            </a:solidFill>
-            <a:effectLst>
-              <a:outerShdw blurRad="50800" dist="38100" dir="5400000" algn="t" rotWithShape="0">
-                <a:prstClr val="black">
-                  <a:alpha val="26000"/>
-                </a:prstClr>
-              </a:outerShdw>
-            </a:effectLst>
-          </p:spPr>
-          <p:style>
-            <a:lnRef idx="0">
-              <a:schemeClr val="accent5"/>
-            </a:lnRef>
-            <a:fillRef idx="3">
-              <a:schemeClr val="accent5"/>
-            </a:fillRef>
-            <a:effectRef idx="3">
-              <a:schemeClr val="accent5"/>
-            </a:effectRef>
-            <a:fontRef idx="minor">
-              <a:schemeClr val="lt1"/>
-            </a:fontRef>
-          </p:style>
-          <p:txBody>
-            <a:bodyPr rtlCol="0" anchor="ctr"/>
-            <a:lstStyle/>
-            <a:p>
-              <a:pPr marL="0" marR="0" lvl="0" indent="0" algn="ctr" defTabSz="914400" rtl="0" eaLnBrk="1" fontAlgn="auto" latinLnBrk="0" hangingPunct="1">
-                <a:lnSpc>
-                  <a:spcPct val="100000"/>
-                </a:lnSpc>
-                <a:spcBef>
-                  <a:spcPts val="0"/>
-                </a:spcBef>
-                <a:spcAft>
-                  <a:spcPts val="0"/>
-                </a:spcAft>
-                <a:buClrTx/>
-                <a:buSzTx/>
-                <a:buFontTx/>
-                <a:buNone/>
-                <a:tabLst/>
-                <a:defRPr/>
-              </a:pPr>
-              <a:endParaRPr kumimoji="0" lang="en-US" sz="1200" b="0" i="0" u="none" strike="noStrike" kern="1200" cap="none" spc="0" normalizeH="0" baseline="0" noProof="0">
-                <a:ln>
-                  <a:noFill/>
-                </a:ln>
-                <a:solidFill>
-                  <a:prstClr val="white"/>
-                </a:solidFill>
-                <a:effectLst/>
-                <a:uLnTx/>
-                <a:uFillTx/>
-                <a:latin typeface="Calibri" panose="020F0502020204030204"/>
-                <a:ea typeface="+mn-ea"/>
-                <a:cs typeface="+mn-cs"/>
-              </a:endParaRPr>
-            </a:p>
-          </p:txBody>
-        </p:sp>
-        <p:pic>
-          <p:nvPicPr>
-            <p:cNvPr id="31" name="Picture 30">
-              <a:extLst>
-                <a:ext uri="{FF2B5EF4-FFF2-40B4-BE49-F238E27FC236}">
-                  <a16:creationId xmlns:a16="http://schemas.microsoft.com/office/drawing/2014/main" id="{3036909C-CF45-6A9D-EEBF-8C306BBC1C4A}"/>
-                </a:ext>
-              </a:extLst>
-            </p:cNvPr>
-            <p:cNvPicPr>
-              <a:picLocks noChangeAspect="1"/>
-            </p:cNvPicPr>
-            <p:nvPr/>
-          </p:nvPicPr>
-          <p:blipFill>
-            <a:blip r:embed="rId2" cstate="print">
-              <a:extLst>
-                <a:ext uri="{28A0092B-C50C-407E-A947-70E740481C1C}">
-                  <a14:useLocalDpi xmlns:a14="http://schemas.microsoft.com/office/drawing/2010/main" val="0"/>
-                </a:ext>
-              </a:extLst>
-            </a:blip>
-            <a:stretch>
-              <a:fillRect/>
-            </a:stretch>
-          </p:blipFill>
-          <p:spPr>
-            <a:xfrm>
-              <a:off x="383951" y="2671349"/>
-              <a:ext cx="2113281" cy="993242"/>
-            </a:xfrm>
-            <a:prstGeom prst="rect">
-              <a:avLst/>
-            </a:prstGeom>
-            <a:effectLst/>
-          </p:spPr>
-        </p:pic>
-        <p:grpSp>
-          <p:nvGrpSpPr>
-            <p:cNvPr id="35" name="Group 34">
-              <a:extLst>
-                <a:ext uri="{FF2B5EF4-FFF2-40B4-BE49-F238E27FC236}">
-                  <a16:creationId xmlns:a16="http://schemas.microsoft.com/office/drawing/2014/main" id="{91F1CC90-5945-B370-3D27-18F200E89F91}"/>
-                </a:ext>
-              </a:extLst>
-            </p:cNvPr>
-            <p:cNvGrpSpPr/>
-            <p:nvPr/>
-          </p:nvGrpSpPr>
-          <p:grpSpPr>
-            <a:xfrm>
-              <a:off x="772326" y="2620494"/>
-              <a:ext cx="1564442" cy="989371"/>
-              <a:chOff x="441439" y="5085942"/>
-              <a:chExt cx="1536142" cy="1062547"/>
-            </a:xfrm>
-          </p:grpSpPr>
-          <p:sp>
-            <p:nvSpPr>
-              <p:cNvPr id="37" name="TextBox 36">
-                <a:extLst>
-                  <a:ext uri="{FF2B5EF4-FFF2-40B4-BE49-F238E27FC236}">
-                    <a16:creationId xmlns:a16="http://schemas.microsoft.com/office/drawing/2014/main" id="{17DC7DEF-4156-874C-A06E-B3252A5E09A8}"/>
-                  </a:ext>
-                </a:extLst>
-              </p:cNvPr>
-              <p:cNvSpPr txBox="1"/>
-              <p:nvPr/>
-            </p:nvSpPr>
-            <p:spPr>
-              <a:xfrm rot="21384788">
-                <a:off x="522407" y="5085942"/>
-                <a:ext cx="1455174" cy="584775"/>
-              </a:xfrm>
-              <a:prstGeom prst="rect">
-                <a:avLst/>
-              </a:prstGeom>
-              <a:noFill/>
-            </p:spPr>
-            <p:txBody>
-              <a:bodyPr wrap="square" rtlCol="0">
-                <a:spAutoFit/>
-              </a:bodyPr>
-              <a:lstStyle/>
-              <a:p>
-                <a:pPr marL="0" marR="0" lvl="0" indent="0" algn="l" defTabSz="914400" rtl="0" eaLnBrk="1" fontAlgn="auto" latinLnBrk="0" hangingPunct="1">
-                  <a:lnSpc>
-                    <a:spcPct val="100000"/>
-                  </a:lnSpc>
-                  <a:spcBef>
-                    <a:spcPts val="0"/>
-                  </a:spcBef>
-                  <a:spcAft>
-                    <a:spcPts val="0"/>
-                  </a:spcAft>
-                  <a:buClrTx/>
-                  <a:buSzTx/>
-                  <a:buFontTx/>
-                  <a:buNone/>
-                  <a:tabLst/>
-                  <a:defRPr/>
-                </a:pPr>
-                <a:r>
-                  <a:rPr kumimoji="0" lang="en-US" sz="3200" b="0" i="0" u="none" strike="noStrike" kern="1200" cap="none" spc="0" normalizeH="0" baseline="0" noProof="0" dirty="0">
-                    <a:ln>
-                      <a:noFill/>
-                    </a:ln>
-                    <a:solidFill>
-                      <a:prstClr val="white"/>
-                    </a:solidFill>
-                    <a:effectLst/>
-                    <a:uLnTx/>
-                    <a:uFillTx/>
-                    <a:latin typeface="Freestyle Script" panose="030804020302050B0404" pitchFamily="66" charset="0"/>
-                    <a:ea typeface="+mn-ea"/>
-                    <a:cs typeface="Dreaming Outloud Script Pro" panose="020F0502020204030204" pitchFamily="66" charset="0"/>
-                  </a:rPr>
-                  <a:t>Graduating</a:t>
-                </a:r>
-                <a:endParaRPr kumimoji="0" lang="en-US" sz="1600" b="0" i="0" u="none" strike="noStrike" kern="1200" cap="none" spc="0" normalizeH="0" baseline="0" noProof="0" dirty="0">
-                  <a:ln>
-                    <a:noFill/>
-                  </a:ln>
-                  <a:solidFill>
-                    <a:prstClr val="white"/>
-                  </a:solidFill>
-                  <a:effectLst/>
-                  <a:uLnTx/>
-                  <a:uFillTx/>
-                  <a:latin typeface="Freestyle Script" panose="030804020302050B0404" pitchFamily="66" charset="0"/>
-                  <a:ea typeface="+mn-ea"/>
-                  <a:cs typeface="Dreaming Outloud Script Pro" panose="020F0502020204030204" pitchFamily="66" charset="0"/>
-                </a:endParaRPr>
-              </a:p>
-            </p:txBody>
-          </p:sp>
-          <p:sp>
-            <p:nvSpPr>
-              <p:cNvPr id="38" name="TextBox 37">
-                <a:extLst>
-                  <a:ext uri="{FF2B5EF4-FFF2-40B4-BE49-F238E27FC236}">
-                    <a16:creationId xmlns:a16="http://schemas.microsoft.com/office/drawing/2014/main" id="{5667C46A-1B81-27AD-F741-64E9EEF39BFA}"/>
-                  </a:ext>
-                </a:extLst>
-              </p:cNvPr>
-              <p:cNvSpPr txBox="1"/>
-              <p:nvPr/>
-            </p:nvSpPr>
-            <p:spPr>
-              <a:xfrm>
-                <a:off x="441439" y="5420992"/>
-                <a:ext cx="1488907" cy="492443"/>
-              </a:xfrm>
-              <a:prstGeom prst="rect">
-                <a:avLst/>
-              </a:prstGeom>
-              <a:noFill/>
-            </p:spPr>
-            <p:txBody>
-              <a:bodyPr wrap="square" rtlCol="0">
-                <a:spAutoFit/>
-              </a:bodyPr>
-              <a:lstStyle/>
-              <a:p>
-                <a:pPr marL="0" marR="0" lvl="0" indent="0" algn="l" defTabSz="914400" rtl="0" eaLnBrk="1" fontAlgn="auto" latinLnBrk="0" hangingPunct="1">
-                  <a:lnSpc>
-                    <a:spcPct val="100000"/>
-                  </a:lnSpc>
-                  <a:spcBef>
-                    <a:spcPts val="0"/>
-                  </a:spcBef>
-                  <a:spcAft>
-                    <a:spcPts val="0"/>
-                  </a:spcAft>
-                  <a:buClrTx/>
-                  <a:buSzTx/>
-                  <a:buFontTx/>
-                  <a:buNone/>
-                  <a:tabLst/>
-                  <a:defRPr/>
-                </a:pPr>
-                <a:r>
-                  <a:rPr kumimoji="0" lang="en-US" sz="2600" b="0" i="0" u="none" strike="noStrike" kern="1200" cap="none" spc="0" normalizeH="0" baseline="0" noProof="0" dirty="0">
-                    <a:ln>
-                      <a:noFill/>
-                    </a:ln>
-                    <a:solidFill>
-                      <a:prstClr val="white"/>
-                    </a:solidFill>
-                    <a:effectLst/>
-                    <a:uLnTx/>
-                    <a:uFillTx/>
-                    <a:latin typeface="Calibri" panose="020F0502020204030204"/>
-                    <a:ea typeface="+mn-ea"/>
-                    <a:cs typeface="+mn-cs"/>
-                  </a:rPr>
-                  <a:t>CLASS OF</a:t>
-                </a:r>
-              </a:p>
-            </p:txBody>
-          </p:sp>
-          <p:sp>
-            <p:nvSpPr>
-              <p:cNvPr id="39" name="TextBox 38">
-                <a:extLst>
-                  <a:ext uri="{FF2B5EF4-FFF2-40B4-BE49-F238E27FC236}">
-                    <a16:creationId xmlns:a16="http://schemas.microsoft.com/office/drawing/2014/main" id="{9F145F92-F10E-9D78-4B32-22B9D86F92B9}"/>
-                  </a:ext>
-                </a:extLst>
-              </p:cNvPr>
-              <p:cNvSpPr txBox="1"/>
-              <p:nvPr/>
-            </p:nvSpPr>
-            <p:spPr>
-              <a:xfrm>
-                <a:off x="506426" y="5718786"/>
-                <a:ext cx="1284478" cy="429703"/>
-              </a:xfrm>
-              <a:prstGeom prst="rect">
-                <a:avLst/>
-              </a:prstGeom>
-              <a:noFill/>
-            </p:spPr>
-            <p:txBody>
-              <a:bodyPr wrap="square" rtlCol="0">
-                <a:spAutoFit/>
-              </a:bodyPr>
-              <a:lstStyle/>
-              <a:p>
-                <a:pPr marL="0" marR="0" lvl="0" indent="0" algn="ctr" defTabSz="914400" rtl="0" eaLnBrk="1" fontAlgn="auto" latinLnBrk="0" hangingPunct="1">
-                  <a:lnSpc>
-                    <a:spcPct val="100000"/>
-                  </a:lnSpc>
-                  <a:spcBef>
-                    <a:spcPts val="0"/>
-                  </a:spcBef>
-                  <a:spcAft>
-                    <a:spcPts val="0"/>
-                  </a:spcAft>
-                  <a:buClrTx/>
-                  <a:buSzTx/>
-                  <a:buFontTx/>
-                  <a:buNone/>
-                  <a:tabLst/>
-                  <a:defRPr/>
-                </a:pPr>
-                <a:r>
-                  <a:rPr kumimoji="0" lang="en-US" sz="2000" b="1" i="0" u="none" strike="noStrike" kern="1200" cap="none" spc="0" normalizeH="0" baseline="0" noProof="0" dirty="0">
-                    <a:ln>
-                      <a:noFill/>
-                    </a:ln>
-                    <a:solidFill>
-                      <a:prstClr val="white"/>
-                    </a:solidFill>
-                    <a:effectLst/>
-                    <a:uLnTx/>
-                    <a:uFillTx/>
-                    <a:latin typeface="Calibri" panose="020F0502020204030204"/>
-                    <a:ea typeface="+mn-ea"/>
-                    <a:cs typeface="+mn-cs"/>
-                  </a:rPr>
-                  <a:t>2024</a:t>
-                </a:r>
-              </a:p>
-            </p:txBody>
-          </p:sp>
-        </p:grpSp>
-      </p:grpSp>
-      <p:pic>
-        <p:nvPicPr>
-          <p:cNvPr id="21" name="Picture 20" descr="A close up of flowers&#10;&#10;Description automatically generated with low confidence">
-            <a:extLst>
-              <a:ext uri="{FF2B5EF4-FFF2-40B4-BE49-F238E27FC236}">
-                <a16:creationId xmlns:a16="http://schemas.microsoft.com/office/drawing/2014/main" id="{E68DA34D-3EC8-AC50-06A2-9225EB820E7B}"/>
+                <a16:creationId xmlns:a16="http://schemas.microsoft.com/office/drawing/2014/main" id="{DED7C1AD-B52C-60B4-B6F4-2B3CD9143DC4}"/>
               </a:ext>
             </a:extLst>
           </p:cNvPr>
@@ -3823,7 +3133,7 @@
           <p:nvPr/>
         </p:nvPicPr>
         <p:blipFill>
-          <a:blip r:embed="rId4" cstate="print">
+          <a:blip r:embed="rId2">
             <a:extLst>
               <a:ext uri="{28A0092B-C50C-407E-A947-70E740481C1C}">
                 <a14:useLocalDpi xmlns:a14="http://schemas.microsoft.com/office/drawing/2010/main" val="0"/>
@@ -3835,154 +3145,133 @@
           </a:stretch>
         </p:blipFill>
         <p:spPr>
-          <a:xfrm rot="10579212">
-            <a:off x="9868907" y="4265479"/>
-            <a:ext cx="3250636" cy="2582449"/>
+          <a:xfrm>
+            <a:off x="0" y="-37850"/>
+            <a:ext cx="18440400" cy="10372725"/>
           </a:xfrm>
           <a:prstGeom prst="rect">
             <a:avLst/>
           </a:prstGeom>
-          <a:noFill/>
         </p:spPr>
       </p:pic>
-      <p:pic>
-        <p:nvPicPr>
-          <p:cNvPr id="20" name="Picture 19" descr="A close up of flowers&#10;&#10;Description automatically generated with low confidence">
+      <p:sp>
+        <p:nvSpPr>
+          <p:cNvPr id="8" name="TextBox 8">
             <a:extLst>
               <a:ext uri="{FF2B5EF4-FFF2-40B4-BE49-F238E27FC236}">
-                <a16:creationId xmlns:a16="http://schemas.microsoft.com/office/drawing/2014/main" id="{49996693-0287-B48C-FD54-0BC6515E7BC7}"/>
+                <a16:creationId xmlns:a16="http://schemas.microsoft.com/office/drawing/2014/main" id="{997F092D-C49B-6519-D519-5EB79E5DD229}"/>
               </a:ext>
             </a:extLst>
           </p:cNvPr>
-          <p:cNvPicPr>
-            <a:picLocks noChangeAspect="1"/>
-          </p:cNvPicPr>
+          <p:cNvSpPr txBox="1"/>
           <p:nvPr/>
-        </p:nvPicPr>
-        <p:blipFill>
-          <a:blip r:embed="rId4" cstate="print">
-            <a:extLst>
-              <a:ext uri="{28A0092B-C50C-407E-A947-70E740481C1C}">
-                <a14:useLocalDpi xmlns:a14="http://schemas.microsoft.com/office/drawing/2010/main" val="0"/>
-              </a:ext>
-            </a:extLst>
-          </a:blip>
-          <a:stretch>
-            <a:fillRect/>
-          </a:stretch>
-        </p:blipFill>
+        </p:nvSpPr>
         <p:spPr>
-          <a:xfrm rot="21075473">
-            <a:off x="-930772" y="4810747"/>
-            <a:ext cx="3250636" cy="2582449"/>
+          <a:xfrm>
+            <a:off x="2916370" y="7769973"/>
+            <a:ext cx="10571029" cy="778996"/>
           </a:xfrm>
           <a:prstGeom prst="rect">
             <a:avLst/>
           </a:prstGeom>
-          <a:noFill/>
         </p:spPr>
-      </p:pic>
+        <p:txBody>
+          <a:bodyPr wrap="square" lIns="0" tIns="0" rIns="0" bIns="0" rtlCol="0" anchor="t">
+            <a:spAutoFit/>
+          </a:bodyPr>
+          <a:lstStyle/>
+          <a:p>
+            <a:pPr algn="l">
+              <a:lnSpc>
+                <a:spcPts val="6723"/>
+              </a:lnSpc>
+            </a:pPr>
+            <a:r>
+              <a:rPr lang="en-US" sz="4000" dirty="0">
+                <a:solidFill>
+                  <a:srgbClr val="18345E"/>
+                </a:solidFill>
+                <a:latin typeface="Anton" pitchFamily="2" charset="77"/>
+                <a:ea typeface="Impact"/>
+                <a:cs typeface="Impact"/>
+                <a:sym typeface="Impact"/>
+              </a:rPr>
+              <a:t>Name</a:t>
+            </a:r>
+            <a:endParaRPr lang="en-US" sz="4000" dirty="0">
+              <a:solidFill>
+                <a:srgbClr val="1DC0DC"/>
+              </a:solidFill>
+              <a:latin typeface="Anton" pitchFamily="2" charset="77"/>
+              <a:ea typeface="Impact"/>
+              <a:cs typeface="Impact"/>
+              <a:sym typeface="Impact"/>
+            </a:endParaRPr>
+          </a:p>
+        </p:txBody>
+      </p:sp>
+      <p:sp>
+        <p:nvSpPr>
+          <p:cNvPr id="9" name="TextBox 9">
+            <a:extLst>
+              <a:ext uri="{FF2B5EF4-FFF2-40B4-BE49-F238E27FC236}">
+                <a16:creationId xmlns:a16="http://schemas.microsoft.com/office/drawing/2014/main" id="{040829AF-DF85-7735-886C-73EE9EE1C51C}"/>
+              </a:ext>
+            </a:extLst>
+          </p:cNvPr>
+          <p:cNvSpPr txBox="1"/>
+          <p:nvPr/>
+        </p:nvSpPr>
+        <p:spPr>
+          <a:xfrm>
+            <a:off x="2916371" y="8724900"/>
+            <a:ext cx="3267846" cy="481330"/>
+          </a:xfrm>
+          <a:prstGeom prst="rect">
+            <a:avLst/>
+          </a:prstGeom>
+        </p:spPr>
+        <p:txBody>
+          <a:bodyPr lIns="0" tIns="0" rIns="0" bIns="0" rtlCol="0" anchor="t">
+            <a:spAutoFit/>
+          </a:bodyPr>
+          <a:lstStyle/>
+          <a:p>
+            <a:pPr algn="l">
+              <a:lnSpc>
+                <a:spcPts val="3919"/>
+              </a:lnSpc>
+            </a:pPr>
+            <a:r>
+              <a:rPr lang="en-US" sz="2799" dirty="0">
+                <a:solidFill>
+                  <a:srgbClr val="FFFFFF"/>
+                </a:solidFill>
+                <a:latin typeface="Calibri" panose="020F0502020204030204" pitchFamily="34" charset="0"/>
+                <a:ea typeface="Titillium Web"/>
+                <a:cs typeface="Calibri" panose="020F0502020204030204" pitchFamily="34" charset="0"/>
+                <a:sym typeface="Titillium Web"/>
+              </a:rPr>
+              <a:t>Graduands</a:t>
+            </a:r>
+          </a:p>
+        </p:txBody>
+      </p:sp>
     </p:spTree>
     <p:extLst>
       <p:ext uri="{BB962C8B-B14F-4D97-AF65-F5344CB8AC3E}">
-        <p14:creationId xmlns:p14="http://schemas.microsoft.com/office/powerpoint/2010/main" val="3005221500"/>
+        <p14:creationId xmlns:p14="http://schemas.microsoft.com/office/powerpoint/2010/main" val="1655490690"/>
       </p:ext>
     </p:extLst>
   </p:cSld>
   <p:clrMapOvr>
     <a:masterClrMapping/>
   </p:clrMapOvr>
-  <p:timing>
-    <p:tnLst>
-      <p:par>
-        <p:cTn id="1" dur="indefinite" restart="never" nodeType="tmRoot">
-          <p:childTnLst>
-            <p:seq concurrent="1" nextAc="seek">
-              <p:cTn id="2" dur="indefinite" nodeType="mainSeq">
-                <p:childTnLst>
-                  <p:par>
-                    <p:cTn id="3" fill="hold">
-                      <p:stCondLst>
-                        <p:cond delay="indefinite"/>
-                        <p:cond evt="onBegin" delay="0">
-                          <p:tn val="2"/>
-                        </p:cond>
-                      </p:stCondLst>
-                      <p:childTnLst>
-                        <p:par>
-                          <p:cTn id="4" fill="hold">
-                            <p:stCondLst>
-                              <p:cond delay="0"/>
-                            </p:stCondLst>
-                            <p:childTnLst>
-                              <p:par>
-                                <p:cTn id="5" presetID="22" presetClass="entr" presetSubtype="8" fill="hold" nodeType="withEffect">
-                                  <p:stCondLst>
-                                    <p:cond delay="0"/>
-                                  </p:stCondLst>
-                                  <p:childTnLst>
-                                    <p:set>
-                                      <p:cBhvr>
-                                        <p:cTn id="6" dur="1" fill="hold">
-                                          <p:stCondLst>
-                                            <p:cond delay="0"/>
-                                          </p:stCondLst>
-                                        </p:cTn>
-                                        <p:tgtEl>
-                                          <p:spTgt spid="40"/>
-                                        </p:tgtEl>
-                                        <p:attrNameLst>
-                                          <p:attrName>style.visibility</p:attrName>
-                                        </p:attrNameLst>
-                                      </p:cBhvr>
-                                      <p:to>
-                                        <p:strVal val="visible"/>
-                                      </p:to>
-                                    </p:set>
-                                    <p:animEffect transition="in" filter="wipe(left)">
-                                      <p:cBhvr>
-                                        <p:cTn id="7" dur="500"/>
-                                        <p:tgtEl>
-                                          <p:spTgt spid="40"/>
-                                        </p:tgtEl>
-                                      </p:cBhvr>
-                                    </p:animEffect>
-                                  </p:childTnLst>
-                                </p:cTn>
-                              </p:par>
-                            </p:childTnLst>
-                          </p:cTn>
-                        </p:par>
-                      </p:childTnLst>
-                    </p:cTn>
-                  </p:par>
-                </p:childTnLst>
-              </p:cTn>
-              <p:prevCondLst>
-                <p:cond evt="onPrev" delay="0">
-                  <p:tgtEl>
-                    <p:sldTgt/>
-                  </p:tgtEl>
-                </p:cond>
-              </p:prevCondLst>
-              <p:nextCondLst>
-                <p:cond evt="onNext" delay="0">
-                  <p:tgtEl>
-                    <p:sldTgt/>
-                  </p:tgtEl>
-                </p:cond>
-              </p:nextCondLst>
-            </p:seq>
-          </p:childTnLst>
-        </p:cTn>
-      </p:par>
-    </p:tnLst>
-  </p:timing>
 </p:sld>
 </file>
 
 <file path=ppt/theme/theme1.xml><?xml version="1.0" encoding="utf-8"?>
-<a:theme xmlns:a="http://schemas.openxmlformats.org/drawingml/2006/main" name="1_Office Theme">
+<a:theme xmlns:a="http://schemas.openxmlformats.org/drawingml/2006/main" name="Office Theme">
   <a:themeElements>
     <a:clrScheme name="Office">
       <a:dk1>
@@ -3992,44 +3281,44 @@
         <a:sysClr val="window" lastClr="FFFFFF"/>
       </a:lt1>
       <a:dk2>
-        <a:srgbClr val="44546A"/>
+        <a:srgbClr val="1F497D"/>
       </a:dk2>
       <a:lt2>
-        <a:srgbClr val="E7E6E6"/>
+        <a:srgbClr val="EEECE1"/>
       </a:lt2>
       <a:accent1>
-        <a:srgbClr val="5B9BD5"/>
+        <a:srgbClr val="4F81BD"/>
       </a:accent1>
       <a:accent2>
-        <a:srgbClr val="ED7D31"/>
+        <a:srgbClr val="C0504D"/>
       </a:accent2>
       <a:accent3>
-        <a:srgbClr val="A5A5A5"/>
+        <a:srgbClr val="9BBB59"/>
       </a:accent3>
       <a:accent4>
-        <a:srgbClr val="FFC000"/>
+        <a:srgbClr val="8064A2"/>
       </a:accent4>
       <a:accent5>
-        <a:srgbClr val="4472C4"/>
+        <a:srgbClr val="4BACC6"/>
       </a:accent5>
       <a:accent6>
-        <a:srgbClr val="70AD47"/>
+        <a:srgbClr val="F79646"/>
       </a:accent6>
       <a:hlink>
-        <a:srgbClr val="0563C1"/>
+        <a:srgbClr val="0000FF"/>
       </a:hlink>
       <a:folHlink>
-        <a:srgbClr val="954F72"/>
+        <a:srgbClr val="800080"/>
       </a:folHlink>
     </a:clrScheme>
     <a:fontScheme name="Office">
       <a:majorFont>
-        <a:latin typeface="Calibri Light" panose="020F0302020204030204"/>
+        <a:latin typeface="Calibri"/>
         <a:ea typeface=""/>
         <a:cs typeface=""/>
-        <a:font script="Jpan" typeface="游ゴシック Light"/>
+        <a:font script="Jpan" typeface="ＭＳ Ｐゴシック"/>
         <a:font script="Hang" typeface="맑은 고딕"/>
-        <a:font script="Hans" typeface="等线 Light"/>
+        <a:font script="Hans" typeface="宋体"/>
         <a:font script="Hant" typeface="新細明體"/>
         <a:font script="Arab" typeface="Times New Roman"/>
         <a:font script="Hebr" typeface="Times New Roman"/>
@@ -4056,15 +3345,14 @@
         <a:font script="Mong" typeface="Mongolian Baiti"/>
         <a:font script="Viet" typeface="Times New Roman"/>
         <a:font script="Uigh" typeface="Microsoft Uighur"/>
-        <a:font script="Geor" typeface="Sylfaen"/>
       </a:majorFont>
       <a:minorFont>
-        <a:latin typeface="Calibri" panose="020F0502020204030204"/>
+        <a:latin typeface="Calibri"/>
         <a:ea typeface=""/>
         <a:cs typeface=""/>
-        <a:font script="Jpan" typeface="游ゴシック"/>
+        <a:font script="Jpan" typeface="ＭＳ Ｐゴシック"/>
         <a:font script="Hang" typeface="맑은 고딕"/>
-        <a:font script="Hans" typeface="等线"/>
+        <a:font script="Hans" typeface="宋体"/>
         <a:font script="Hant" typeface="新細明體"/>
         <a:font script="Arab" typeface="Arial"/>
         <a:font script="Hebr" typeface="Arial"/>
@@ -4091,7 +3379,6 @@
         <a:font script="Mong" typeface="Mongolian Baiti"/>
         <a:font script="Viet" typeface="Arial"/>
         <a:font script="Uigh" typeface="Microsoft Uighur"/>
-        <a:font script="Geor" typeface="Sylfaen"/>
       </a:minorFont>
     </a:fontScheme>
     <a:fmtScheme name="Office">
@@ -4103,440 +3390,165 @@
           <a:gsLst>
             <a:gs pos="0">
               <a:schemeClr val="phClr">
-                <a:lumMod val="110000"/>
-                <a:satMod val="105000"/>
-                <a:tint val="67000"/>
+                <a:tint val="50000"/>
+                <a:satMod val="300000"/>
               </a:schemeClr>
             </a:gs>
-            <a:gs pos="50000">
+            <a:gs pos="35000">
               <a:schemeClr val="phClr">
-                <a:lumMod val="105000"/>
-                <a:satMod val="103000"/>
-                <a:tint val="73000"/>
+                <a:tint val="37000"/>
+                <a:satMod val="300000"/>
               </a:schemeClr>
             </a:gs>
             <a:gs pos="100000">
               <a:schemeClr val="phClr">
-                <a:lumMod val="105000"/>
-                <a:satMod val="109000"/>
-                <a:tint val="81000"/>
+                <a:tint val="15000"/>
+                <a:satMod val="350000"/>
               </a:schemeClr>
             </a:gs>
           </a:gsLst>
-          <a:lin ang="5400000" scaled="0"/>
+          <a:lin ang="16200000" scaled="1"/>
         </a:gradFill>
         <a:gradFill rotWithShape="1">
           <a:gsLst>
             <a:gs pos="0">
               <a:schemeClr val="phClr">
-                <a:satMod val="103000"/>
-                <a:lumMod val="102000"/>
-                <a:tint val="94000"/>
+                <a:shade val="51000"/>
+                <a:satMod val="130000"/>
               </a:schemeClr>
             </a:gs>
-            <a:gs pos="50000">
+            <a:gs pos="80000">
               <a:schemeClr val="phClr">
-                <a:satMod val="110000"/>
-                <a:lumMod val="100000"/>
-                <a:shade val="100000"/>
+                <a:shade val="93000"/>
+                <a:satMod val="130000"/>
               </a:schemeClr>
             </a:gs>
             <a:gs pos="100000">
               <a:schemeClr val="phClr">
-                <a:lumMod val="99000"/>
-                <a:satMod val="120000"/>
-                <a:shade val="78000"/>
+                <a:shade val="94000"/>
+                <a:satMod val="135000"/>
               </a:schemeClr>
             </a:gs>
           </a:gsLst>
-          <a:lin ang="5400000" scaled="0"/>
+          <a:lin ang="16200000" scaled="0"/>
         </a:gradFill>
       </a:fillStyleLst>
       <a:lnStyleLst>
-        <a:ln w="6350" cap="flat" cmpd="sng" algn="ctr">
+        <a:ln w="9525" cap="flat" cmpd="sng" algn="ctr">
+          <a:solidFill>
+            <a:schemeClr val="phClr">
+              <a:shade val="95000"/>
+              <a:satMod val="105000"/>
+            </a:schemeClr>
+          </a:solidFill>
+          <a:prstDash val="solid"/>
+        </a:ln>
+        <a:ln w="25400" cap="flat" cmpd="sng" algn="ctr">
           <a:solidFill>
             <a:schemeClr val="phClr"/>
           </a:solidFill>
           <a:prstDash val="solid"/>
-          <a:miter lim="800000"/>
         </a:ln>
-        <a:ln w="12700" cap="flat" cmpd="sng" algn="ctr">
+        <a:ln w="38100" cap="flat" cmpd="sng" algn="ctr">
           <a:solidFill>
             <a:schemeClr val="phClr"/>
           </a:solidFill>
           <a:prstDash val="solid"/>
-          <a:miter lim="800000"/>
-        </a:ln>
-        <a:ln w="19050" cap="flat" cmpd="sng" algn="ctr">
-          <a:solidFill>
-            <a:schemeClr val="phClr"/>
-          </a:solidFill>
-          <a:prstDash val="solid"/>
-          <a:miter lim="800000"/>
         </a:ln>
       </a:lnStyleLst>
       <a:effectStyleLst>
         <a:effectStyle>
-          <a:effectLst/>
-        </a:effectStyle>
-        <a:effectStyle>
-          <a:effectLst/>
+          <a:effectLst>
+            <a:outerShdw blurRad="40000" dist="20000" dir="5400000" rotWithShape="0">
+              <a:srgbClr val="000000">
+                <a:alpha val="38000"/>
+              </a:srgbClr>
+            </a:outerShdw>
+          </a:effectLst>
         </a:effectStyle>
         <a:effectStyle>
           <a:effectLst>
-            <a:outerShdw blurRad="57150" dist="19050" dir="5400000" algn="ctr" rotWithShape="0">
+            <a:outerShdw blurRad="40000" dist="23000" dir="5400000" rotWithShape="0">
               <a:srgbClr val="000000">
-                <a:alpha val="63000"/>
+                <a:alpha val="35000"/>
               </a:srgbClr>
             </a:outerShdw>
           </a:effectLst>
+        </a:effectStyle>
+        <a:effectStyle>
+          <a:effectLst>
+            <a:outerShdw blurRad="40000" dist="23000" dir="5400000" rotWithShape="0">
+              <a:srgbClr val="000000">
+                <a:alpha val="35000"/>
+              </a:srgbClr>
+            </a:outerShdw>
+          </a:effectLst>
+          <a:scene3d>
+            <a:camera prst="orthographicFront">
+              <a:rot lat="0" lon="0" rev="0"/>
+            </a:camera>
+            <a:lightRig rig="threePt" dir="t">
+              <a:rot lat="0" lon="0" rev="1200000"/>
+            </a:lightRig>
+          </a:scene3d>
+          <a:sp3d>
+            <a:bevelT w="63500" h="25400"/>
+          </a:sp3d>
         </a:effectStyle>
       </a:effectStyleLst>
       <a:bgFillStyleLst>
         <a:solidFill>
           <a:schemeClr val="phClr"/>
         </a:solidFill>
-        <a:solidFill>
-          <a:schemeClr val="phClr">
-            <a:tint val="95000"/>
-            <a:satMod val="170000"/>
-          </a:schemeClr>
-        </a:solidFill>
         <a:gradFill rotWithShape="1">
           <a:gsLst>
             <a:gs pos="0">
               <a:schemeClr val="phClr">
-                <a:tint val="93000"/>
-                <a:satMod val="150000"/>
-                <a:shade val="98000"/>
-                <a:lumMod val="102000"/>
+                <a:tint val="40000"/>
+                <a:satMod val="350000"/>
               </a:schemeClr>
             </a:gs>
-            <a:gs pos="50000">
+            <a:gs pos="40000">
               <a:schemeClr val="phClr">
-                <a:tint val="98000"/>
-                <a:satMod val="130000"/>
-                <a:shade val="90000"/>
-                <a:lumMod val="103000"/>
+                <a:tint val="45000"/>
+                <a:shade val="99000"/>
+                <a:satMod val="350000"/>
               </a:schemeClr>
             </a:gs>
             <a:gs pos="100000">
               <a:schemeClr val="phClr">
-                <a:shade val="63000"/>
-                <a:satMod val="120000"/>
+                <a:shade val="20000"/>
+                <a:satMod val="255000"/>
               </a:schemeClr>
             </a:gs>
           </a:gsLst>
-          <a:lin ang="5400000" scaled="0"/>
+          <a:path path="circle">
+            <a:fillToRect l="50000" t="-80000" r="50000" b="180000"/>
+          </a:path>
+        </a:gradFill>
+        <a:gradFill rotWithShape="1">
+          <a:gsLst>
+            <a:gs pos="0">
+              <a:schemeClr val="phClr">
+                <a:tint val="80000"/>
+                <a:satMod val="300000"/>
+              </a:schemeClr>
+            </a:gs>
+            <a:gs pos="100000">
+              <a:schemeClr val="phClr">
+                <a:shade val="30000"/>
+                <a:satMod val="200000"/>
+              </a:schemeClr>
+            </a:gs>
+          </a:gsLst>
+          <a:path path="circle">
+            <a:fillToRect l="50000" t="50000" r="50000" b="50000"/>
+          </a:path>
         </a:gradFill>
       </a:bgFillStyleLst>
     </a:fmtScheme>
   </a:themeElements>
   <a:objectDefaults/>
   <a:extraClrSchemeLst/>
-  <a:extLst>
-    <a:ext uri="{05A4C25C-085E-4340-85A3-A5531E510DB2}">
-      <thm15:themeFamily xmlns:thm15="http://schemas.microsoft.com/office/thememl/2012/main" name="Office Theme" id="{62F939B6-93AF-4DB8-9C6B-D6C7DFDC589F}" vid="{4A3C46E8-61CC-4603-A589-7422A47A8E4A}"/>
-    </a:ext>
-  </a:extLst>
 </a:theme>
-</file>
-
-<file path=customXml/item1.xml><?xml version="1.0" encoding="utf-8"?>
-<?mso-contentType ?>
-<FormTemplates xmlns="http://schemas.microsoft.com/sharepoint/v3/contenttype/forms">
-  <Display>DocumentLibraryForm</Display>
-  <Edit>DocumentLibraryForm</Edit>
-  <New>DocumentLibraryForm</New>
-</FormTemplates>
-</file>
-
-<file path=customXml/item2.xml><?xml version="1.0" encoding="utf-8"?>
-<ct:contentTypeSchema xmlns:ct="http://schemas.microsoft.com/office/2006/metadata/contentType" xmlns:ma="http://schemas.microsoft.com/office/2006/metadata/properties/metaAttributes" ct:_="" ma:_="" ma:contentTypeName="Document" ma:contentTypeID="0x010100E9C67ECBDBE2B0448B880705BE94987C" ma:contentTypeVersion="16" ma:contentTypeDescription="Create a new document." ma:contentTypeScope="" ma:versionID="8ab3cc323974e07f6dbf9fa9b6647b7f">
-  <xsd:schema xmlns:xsd="http://www.w3.org/2001/XMLSchema" xmlns:xs="http://www.w3.org/2001/XMLSchema" xmlns:p="http://schemas.microsoft.com/office/2006/metadata/properties" xmlns:ns2="1f6424c7-b46c-4730-a03c-657cbffc3437" xmlns:ns3="370159ea-8a26-4fa8-a627-5b0d5e426c81" targetNamespace="http://schemas.microsoft.com/office/2006/metadata/properties" ma:root="true" ma:fieldsID="ebb7b0329043561acd432ebe95639abc" ns2:_="" ns3:_="">
-    <xsd:import namespace="1f6424c7-b46c-4730-a03c-657cbffc3437"/>
-    <xsd:import namespace="370159ea-8a26-4fa8-a627-5b0d5e426c81"/>
-    <xsd:element name="properties">
-      <xsd:complexType>
-        <xsd:sequence>
-          <xsd:element name="documentManagement">
-            <xsd:complexType>
-              <xsd:all>
-                <xsd:element ref="ns2:MediaServiceMetadata" minOccurs="0"/>
-                <xsd:element ref="ns2:MediaServiceFastMetadata" minOccurs="0"/>
-                <xsd:element ref="ns2:MediaServiceDateTaken" minOccurs="0"/>
-                <xsd:element ref="ns2:MediaServiceAutoTags" minOccurs="0"/>
-                <xsd:element ref="ns2:MediaServiceOCR" minOccurs="0"/>
-                <xsd:element ref="ns2:MediaServiceGenerationTime" minOccurs="0"/>
-                <xsd:element ref="ns2:MediaServiceEventHashCode" minOccurs="0"/>
-                <xsd:element ref="ns3:SharedWithUsers" minOccurs="0"/>
-                <xsd:element ref="ns3:SharedWithDetails" minOccurs="0"/>
-                <xsd:element ref="ns2:MediaServiceLocation" minOccurs="0"/>
-                <xsd:element ref="ns2:MediaLengthInSeconds" minOccurs="0"/>
-                <xsd:element ref="ns2:lcf76f155ced4ddcb4097134ff3c332f" minOccurs="0"/>
-                <xsd:element ref="ns3:TaxCatchAll" minOccurs="0"/>
-                <xsd:element ref="ns2:MediaServiceObjectDetectorVersions" minOccurs="0"/>
-                <xsd:element ref="ns2:MediaServiceSearchProperties" minOccurs="0"/>
-              </xsd:all>
-            </xsd:complexType>
-          </xsd:element>
-        </xsd:sequence>
-      </xsd:complexType>
-    </xsd:element>
-  </xsd:schema>
-  <xsd:schema xmlns:xsd="http://www.w3.org/2001/XMLSchema" xmlns:xs="http://www.w3.org/2001/XMLSchema" xmlns:dms="http://schemas.microsoft.com/office/2006/documentManagement/types" xmlns:pc="http://schemas.microsoft.com/office/infopath/2007/PartnerControls" targetNamespace="1f6424c7-b46c-4730-a03c-657cbffc3437" elementFormDefault="qualified">
-    <xsd:import namespace="http://schemas.microsoft.com/office/2006/documentManagement/types"/>
-    <xsd:import namespace="http://schemas.microsoft.com/office/infopath/2007/PartnerControls"/>
-    <xsd:element name="MediaServiceMetadata" ma:index="8" nillable="true" ma:displayName="MediaServiceMetadata" ma:hidden="true" ma:internalName="MediaServiceMetadata" ma:readOnly="true">
-      <xsd:simpleType>
-        <xsd:restriction base="dms:Note"/>
-      </xsd:simpleType>
-    </xsd:element>
-    <xsd:element name="MediaServiceFastMetadata" ma:index="9" nillable="true" ma:displayName="MediaServiceFastMetadata" ma:hidden="true" ma:internalName="MediaServiceFastMetadata" ma:readOnly="true">
-      <xsd:simpleType>
-        <xsd:restriction base="dms:Note"/>
-      </xsd:simpleType>
-    </xsd:element>
-    <xsd:element name="MediaServiceDateTaken" ma:index="10" nillable="true" ma:displayName="MediaServiceDateTaken" ma:hidden="true" ma:internalName="MediaServiceDateTaken" ma:readOnly="true">
-      <xsd:simpleType>
-        <xsd:restriction base="dms:Text"/>
-      </xsd:simpleType>
-    </xsd:element>
-    <xsd:element name="MediaServiceAutoTags" ma:index="11" nillable="true" ma:displayName="Tags" ma:internalName="MediaServiceAutoTags" ma:readOnly="true">
-      <xsd:simpleType>
-        <xsd:restriction base="dms:Text"/>
-      </xsd:simpleType>
-    </xsd:element>
-    <xsd:element name="MediaServiceOCR" ma:index="12" nillable="true" ma:displayName="Extracted Text" ma:internalName="MediaServiceOCR" ma:readOnly="true">
-      <xsd:simpleType>
-        <xsd:restriction base="dms:Note">
-          <xsd:maxLength value="255"/>
-        </xsd:restriction>
-      </xsd:simpleType>
-    </xsd:element>
-    <xsd:element name="MediaServiceGenerationTime" ma:index="13" nillable="true" ma:displayName="MediaServiceGenerationTime" ma:hidden="true" ma:internalName="MediaServiceGenerationTime" ma:readOnly="true">
-      <xsd:simpleType>
-        <xsd:restriction base="dms:Text"/>
-      </xsd:simpleType>
-    </xsd:element>
-    <xsd:element name="MediaServiceEventHashCode" ma:index="14" nillable="true" ma:displayName="MediaServiceEventHashCode" ma:hidden="true" ma:internalName="MediaServiceEventHashCode" ma:readOnly="true">
-      <xsd:simpleType>
-        <xsd:restriction base="dms:Text"/>
-      </xsd:simpleType>
-    </xsd:element>
-    <xsd:element name="MediaServiceLocation" ma:index="17" nillable="true" ma:displayName="Location" ma:indexed="true" ma:internalName="MediaServiceLocation" ma:readOnly="true">
-      <xsd:simpleType>
-        <xsd:restriction base="dms:Text"/>
-      </xsd:simpleType>
-    </xsd:element>
-    <xsd:element name="MediaLengthInSeconds" ma:index="18" nillable="true" ma:displayName="MediaLengthInSeconds" ma:hidden="true" ma:internalName="MediaLengthInSeconds" ma:readOnly="true">
-      <xsd:simpleType>
-        <xsd:restriction base="dms:Unknown"/>
-      </xsd:simpleType>
-    </xsd:element>
-    <xsd:element name="lcf76f155ced4ddcb4097134ff3c332f" ma:index="20" nillable="true" ma:taxonomy="true" ma:internalName="lcf76f155ced4ddcb4097134ff3c332f" ma:taxonomyFieldName="MediaServiceImageTags" ma:displayName="Image Tags" ma:readOnly="false" ma:fieldId="{5cf76f15-5ced-4ddc-b409-7134ff3c332f}" ma:taxonomyMulti="true" ma:sspId="c4e55627-389c-40b3-ae15-d813354d2065" ma:termSetId="09814cd3-568e-fe90-9814-8d621ff8fb84" ma:anchorId="fba54fb3-c3e1-fe81-a776-ca4b69148c4d" ma:open="true" ma:isKeyword="false">
-      <xsd:complexType>
-        <xsd:sequence>
-          <xsd:element ref="pc:Terms" minOccurs="0" maxOccurs="1"/>
-        </xsd:sequence>
-      </xsd:complexType>
-    </xsd:element>
-    <xsd:element name="MediaServiceObjectDetectorVersions" ma:index="22" nillable="true" ma:displayName="MediaServiceObjectDetectorVersions" ma:hidden="true" ma:indexed="true" ma:internalName="MediaServiceObjectDetectorVersions" ma:readOnly="true">
-      <xsd:simpleType>
-        <xsd:restriction base="dms:Text"/>
-      </xsd:simpleType>
-    </xsd:element>
-    <xsd:element name="MediaServiceSearchProperties" ma:index="23" nillable="true" ma:displayName="MediaServiceSearchProperties" ma:hidden="true" ma:internalName="MediaServiceSearchProperties" ma:readOnly="true">
-      <xsd:simpleType>
-        <xsd:restriction base="dms:Note"/>
-      </xsd:simpleType>
-    </xsd:element>
-  </xsd:schema>
-  <xsd:schema xmlns:xsd="http://www.w3.org/2001/XMLSchema" xmlns:xs="http://www.w3.org/2001/XMLSchema" xmlns:dms="http://schemas.microsoft.com/office/2006/documentManagement/types" xmlns:pc="http://schemas.microsoft.com/office/infopath/2007/PartnerControls" targetNamespace="370159ea-8a26-4fa8-a627-5b0d5e426c81" elementFormDefault="qualified">
-    <xsd:import namespace="http://schemas.microsoft.com/office/2006/documentManagement/types"/>
-    <xsd:import namespace="http://schemas.microsoft.com/office/infopath/2007/PartnerControls"/>
-    <xsd:element name="SharedWithUsers" ma:index="15" nillable="true" ma:displayName="Shared With" ma:internalName="SharedWithUsers" ma:readOnly="true">
-      <xsd:complexType>
-        <xsd:complexContent>
-          <xsd:extension base="dms:UserMulti">
-            <xsd:sequence>
-              <xsd:element name="UserInfo" minOccurs="0" maxOccurs="unbounded">
-                <xsd:complexType>
-                  <xsd:sequence>
-                    <xsd:element name="DisplayName" type="xsd:string" minOccurs="0"/>
-                    <xsd:element name="AccountId" type="dms:UserId" minOccurs="0" nillable="true"/>
-                    <xsd:element name="AccountType" type="xsd:string" minOccurs="0"/>
-                  </xsd:sequence>
-                </xsd:complexType>
-              </xsd:element>
-            </xsd:sequence>
-          </xsd:extension>
-        </xsd:complexContent>
-      </xsd:complexType>
-    </xsd:element>
-    <xsd:element name="SharedWithDetails" ma:index="16" nillable="true" ma:displayName="Shared With Details" ma:internalName="SharedWithDetails" ma:readOnly="true">
-      <xsd:simpleType>
-        <xsd:restriction base="dms:Note">
-          <xsd:maxLength value="255"/>
-        </xsd:restriction>
-      </xsd:simpleType>
-    </xsd:element>
-    <xsd:element name="TaxCatchAll" ma:index="21" nillable="true" ma:displayName="Taxonomy Catch All Column" ma:hidden="true" ma:list="{97490444-b5bb-42a8-b2c3-9185c8447f0e}" ma:internalName="TaxCatchAll" ma:showField="CatchAllData" ma:web="370159ea-8a26-4fa8-a627-5b0d5e426c81">
-      <xsd:complexType>
-        <xsd:complexContent>
-          <xsd:extension base="dms:MultiChoiceLookup">
-            <xsd:sequence>
-              <xsd:element name="Value" type="dms:Lookup" maxOccurs="unbounded" minOccurs="0" nillable="true"/>
-            </xsd:sequence>
-          </xsd:extension>
-        </xsd:complexContent>
-      </xsd:complexType>
-    </xsd:element>
-  </xsd:schema>
-  <xsd:schema xmlns="http://schemas.openxmlformats.org/package/2006/metadata/core-properties" xmlns:xsd="http://www.w3.org/2001/XMLSchema" xmlns:xsi="http://www.w3.org/2001/XMLSchema-instance" xmlns:dc="http://purl.org/dc/elements/1.1/" xmlns:dcterms="http://purl.org/dc/terms/" xmlns:odoc="http://schemas.microsoft.com/internal/obd" targetNamespace="http://schemas.openxmlformats.org/package/2006/metadata/core-properties" elementFormDefault="qualified" attributeFormDefault="unqualified" blockDefault="#all">
-    <xsd:import namespace="http://purl.org/dc/elements/1.1/" schemaLocation="http://dublincore.org/schemas/xmls/qdc/2003/04/02/dc.xsd"/>
-    <xsd:import namespace="http://purl.org/dc/terms/" schemaLocation="http://dublincore.org/schemas/xmls/qdc/2003/04/02/dcterms.xsd"/>
-    <xsd:element name="coreProperties" type="CT_coreProperties"/>
-    <xsd:complexType name="CT_coreProperties">
-      <xsd:all>
-        <xsd:element ref="dc:creator" minOccurs="0" maxOccurs="1"/>
-        <xsd:element ref="dcterms:created" minOccurs="0" maxOccurs="1"/>
-        <xsd:element ref="dc:identifier" minOccurs="0" maxOccurs="1"/>
-        <xsd:element name="contentType" minOccurs="0" maxOccurs="1" type="xsd:string" ma:index="0" ma:displayName="Content Type"/>
-        <xsd:element ref="dc:title" minOccurs="0" maxOccurs="1" ma:index="4" ma:displayName="Title"/>
-        <xsd:element ref="dc:subject" minOccurs="0" maxOccurs="1"/>
-        <xsd:element ref="dc:description" minOccurs="0" maxOccurs="1"/>
-        <xsd:element name="keywords" minOccurs="0" maxOccurs="1" type="xsd:string"/>
-        <xsd:element ref="dc:language" minOccurs="0" maxOccurs="1"/>
-        <xsd:element name="category" minOccurs="0" maxOccurs="1" type="xsd:string"/>
-        <xsd:element name="version" minOccurs="0" maxOccurs="1" type="xsd:string"/>
-        <xsd:element name="revision" minOccurs="0" maxOccurs="1" type="xsd:string">
-          <xsd:annotation>
-            <xsd:documentation>
-                        This value indicates the number of saves or revisions. The application is responsible for updating this value after each revision.
-                    </xsd:documentation>
-          </xsd:annotation>
-        </xsd:element>
-        <xsd:element name="lastModifiedBy" minOccurs="0" maxOccurs="1" type="xsd:string"/>
-        <xsd:element ref="dcterms:modified" minOccurs="0" maxOccurs="1"/>
-        <xsd:element name="contentStatus" minOccurs="0" maxOccurs="1" type="xsd:string"/>
-      </xsd:all>
-    </xsd:complexType>
-  </xsd:schema>
-  <xs:schema xmlns:pc="http://schemas.microsoft.com/office/infopath/2007/PartnerControls" xmlns:xs="http://www.w3.org/2001/XMLSchema" targetNamespace="http://schemas.microsoft.com/office/infopath/2007/PartnerControls" elementFormDefault="qualified" attributeFormDefault="unqualified">
-    <xs:element name="Person">
-      <xs:complexType>
-        <xs:sequence>
-          <xs:element ref="pc:DisplayName" minOccurs="0"/>
-          <xs:element ref="pc:AccountId" minOccurs="0"/>
-          <xs:element ref="pc:AccountType" minOccurs="0"/>
-        </xs:sequence>
-      </xs:complexType>
-    </xs:element>
-    <xs:element name="DisplayName" type="xs:string"/>
-    <xs:element name="AccountId" type="xs:string"/>
-    <xs:element name="AccountType" type="xs:string"/>
-    <xs:element name="BDCAssociatedEntity">
-      <xs:complexType>
-        <xs:sequence>
-          <xs:element ref="pc:BDCEntity" minOccurs="0" maxOccurs="unbounded"/>
-        </xs:sequence>
-        <xs:attribute ref="pc:EntityNamespace"/>
-        <xs:attribute ref="pc:EntityName"/>
-        <xs:attribute ref="pc:SystemInstanceName"/>
-        <xs:attribute ref="pc:AssociationName"/>
-      </xs:complexType>
-    </xs:element>
-    <xs:attribute name="EntityNamespace" type="xs:string"/>
-    <xs:attribute name="EntityName" type="xs:string"/>
-    <xs:attribute name="SystemInstanceName" type="xs:string"/>
-    <xs:attribute name="AssociationName" type="xs:string"/>
-    <xs:element name="BDCEntity">
-      <xs:complexType>
-        <xs:sequence>
-          <xs:element ref="pc:EntityDisplayName" minOccurs="0"/>
-          <xs:element ref="pc:EntityInstanceReference" minOccurs="0"/>
-          <xs:element ref="pc:EntityId1" minOccurs="0"/>
-          <xs:element ref="pc:EntityId2" minOccurs="0"/>
-          <xs:element ref="pc:EntityId3" minOccurs="0"/>
-          <xs:element ref="pc:EntityId4" minOccurs="0"/>
-          <xs:element ref="pc:EntityId5" minOccurs="0"/>
-        </xs:sequence>
-      </xs:complexType>
-    </xs:element>
-    <xs:element name="EntityDisplayName" type="xs:string"/>
-    <xs:element name="EntityInstanceReference" type="xs:string"/>
-    <xs:element name="EntityId1" type="xs:string"/>
-    <xs:element name="EntityId2" type="xs:string"/>
-    <xs:element name="EntityId3" type="xs:string"/>
-    <xs:element name="EntityId4" type="xs:string"/>
-    <xs:element name="EntityId5" type="xs:string"/>
-    <xs:element name="Terms">
-      <xs:complexType>
-        <xs:sequence>
-          <xs:element ref="pc:TermInfo" minOccurs="0" maxOccurs="unbounded"/>
-        </xs:sequence>
-      </xs:complexType>
-    </xs:element>
-    <xs:element name="TermInfo">
-      <xs:complexType>
-        <xs:sequence>
-          <xs:element ref="pc:TermName" minOccurs="0"/>
-          <xs:element ref="pc:TermId" minOccurs="0"/>
-        </xs:sequence>
-      </xs:complexType>
-    </xs:element>
-    <xs:element name="TermName" type="xs:string"/>
-    <xs:element name="TermId" type="xs:string"/>
-  </xs:schema>
-</ct:contentTypeSchema>
-</file>
-
-<file path=customXml/item3.xml><?xml version="1.0" encoding="utf-8"?>
-<p:properties xmlns:p="http://schemas.microsoft.com/office/2006/metadata/properties" xmlns:xsi="http://www.w3.org/2001/XMLSchema-instance" xmlns:pc="http://schemas.microsoft.com/office/infopath/2007/PartnerControls">
-  <documentManagement>
-    <lcf76f155ced4ddcb4097134ff3c332f xmlns="1f6424c7-b46c-4730-a03c-657cbffc3437">
-      <Terms xmlns="http://schemas.microsoft.com/office/infopath/2007/PartnerControls"/>
-    </lcf76f155ced4ddcb4097134ff3c332f>
-    <TaxCatchAll xmlns="370159ea-8a26-4fa8-a627-5b0d5e426c81" xsi:nil="true"/>
-  </documentManagement>
-</p:properties>
-</file>
-
-<file path=customXml/itemProps1.xml><?xml version="1.0" encoding="utf-8"?>
-<ds:datastoreItem xmlns:ds="http://schemas.openxmlformats.org/officeDocument/2006/customXml" ds:itemID="{CFB87649-5FBC-435D-B5F0-F669B745AE0D}">
-  <ds:schemaRefs>
-    <ds:schemaRef ds:uri="http://schemas.microsoft.com/sharepoint/v3/contenttype/forms"/>
-  </ds:schemaRefs>
-</ds:datastoreItem>
-</file>
-
-<file path=customXml/itemProps2.xml><?xml version="1.0" encoding="utf-8"?>
-<ds:datastoreItem xmlns:ds="http://schemas.openxmlformats.org/officeDocument/2006/customXml" ds:itemID="{DBD8E95E-1FCC-484E-A85C-A06AA35215FC}">
-  <ds:schemaRefs>
-    <ds:schemaRef ds:uri="http://schemas.microsoft.com/office/2006/metadata/contentType"/>
-    <ds:schemaRef ds:uri="http://schemas.microsoft.com/office/2006/metadata/properties/metaAttributes"/>
-    <ds:schemaRef ds:uri="http://www.w3.org/2001/XMLSchema"/>
-    <ds:schemaRef ds:uri="http://schemas.microsoft.com/office/2006/metadata/properties"/>
-    <ds:schemaRef ds:uri="1f6424c7-b46c-4730-a03c-657cbffc3437"/>
-    <ds:schemaRef ds:uri="370159ea-8a26-4fa8-a627-5b0d5e426c81"/>
-    <ds:schemaRef ds:uri="http://schemas.microsoft.com/office/2006/documentManagement/types"/>
-    <ds:schemaRef ds:uri="http://schemas.microsoft.com/office/infopath/2007/PartnerControls"/>
-    <ds:schemaRef ds:uri="http://schemas.openxmlformats.org/package/2006/metadata/core-properties"/>
-    <ds:schemaRef ds:uri="http://purl.org/dc/elements/1.1/"/>
-    <ds:schemaRef ds:uri="http://purl.org/dc/terms/"/>
-    <ds:schemaRef ds:uri="http://schemas.microsoft.com/internal/obd"/>
-  </ds:schemaRefs>
-</ds:datastoreItem>
-</file>
-
-<file path=customXml/itemProps3.xml><?xml version="1.0" encoding="utf-8"?>
-<ds:datastoreItem xmlns:ds="http://schemas.openxmlformats.org/officeDocument/2006/customXml" ds:itemID="{26D3689C-D73D-4B42-BF22-C2DF4DBA87F0}">
-  <ds:schemaRefs>
-    <ds:schemaRef ds:uri="http://schemas.microsoft.com/office/2006/metadata/properties"/>
-    <ds:schemaRef ds:uri="http://schemas.microsoft.com/office/infopath/2007/PartnerControls"/>
-    <ds:schemaRef ds:uri="1f6424c7-b46c-4730-a03c-657cbffc3437"/>
-    <ds:schemaRef ds:uri="370159ea-8a26-4fa8-a627-5b0d5e426c81"/>
-  </ds:schemaRefs>
-</ds:datastoreItem>
 </file>
</xml_diff>